<commit_message>
Add targeted module slide diagrams
</commit_message>
<xml_diff>
--- a/downloads/presentations/modules/anl-200.pptx
+++ b/downloads/presentations/modules/anl-200.pptx
@@ -3418,11 +3418,11 @@
         <p:spPr>
           <a:xfrm>
             <a:off x="7635240" y="1325880"/>
-            <a:ext cx="3474720" cy="1325880"/>
+            <a:ext cx="3474720" cy="1207008"/>
           </a:xfrm>
           <a:prstGeom prst="roundRect">
             <a:avLst>
-              <a:gd name="adj" fmla="val 8276"/>
+              <a:gd name="adj" fmla="val 9091"/>
             </a:avLst>
           </a:prstGeom>
           <a:solidFill>
@@ -3484,7 +3484,7 @@
         <p:spPr>
           <a:xfrm>
             <a:off x="7799832" y="1801368"/>
-            <a:ext cx="3145536" cy="758952"/>
+            <a:ext cx="3145536" cy="640080"/>
           </a:xfrm>
           <a:prstGeom prst="rect">
             <a:avLst/>
@@ -3524,12 +3524,12 @@
         </p:nvSpPr>
         <p:spPr>
           <a:xfrm>
-            <a:off x="7635240" y="2788920"/>
-            <a:ext cx="3474720" cy="1536192"/>
+            <a:off x="7635240" y="2670048"/>
+            <a:ext cx="3474720" cy="1377086"/>
           </a:xfrm>
           <a:prstGeom prst="roundRect">
             <a:avLst>
-              <a:gd name="adj" fmla="val 7143"/>
+              <a:gd name="adj" fmla="val 7968"/>
             </a:avLst>
           </a:prstGeom>
           <a:solidFill>
@@ -3551,7 +3551,7 @@
         </p:nvSpPr>
         <p:spPr>
           <a:xfrm>
-            <a:off x="7799832" y="2935224"/>
+            <a:off x="7799832" y="2816352"/>
             <a:ext cx="3145536" cy="256032"/>
           </a:xfrm>
           <a:prstGeom prst="rect">
@@ -3590,8 +3590,8 @@
         </p:nvSpPr>
         <p:spPr>
           <a:xfrm>
-            <a:off x="7818120" y="3300984"/>
-            <a:ext cx="3090672" cy="877824"/>
+            <a:off x="7818120" y="3182112"/>
+            <a:ext cx="3090672" cy="718718"/>
           </a:xfrm>
           <a:prstGeom prst="rect">
             <a:avLst/>
@@ -3665,12 +3665,12 @@
         </p:nvSpPr>
         <p:spPr>
           <a:xfrm>
-            <a:off x="7635240" y="4498848"/>
-            <a:ext cx="3474720" cy="1143000"/>
+            <a:off x="7635240" y="4184294"/>
+            <a:ext cx="3474720" cy="1466698"/>
           </a:xfrm>
           <a:prstGeom prst="roundRect">
             <a:avLst>
-              <a:gd name="adj" fmla="val 9600"/>
+              <a:gd name="adj" fmla="val 7481"/>
             </a:avLst>
           </a:prstGeom>
           <a:solidFill>
@@ -3692,7 +3692,7 @@
         </p:nvSpPr>
         <p:spPr>
           <a:xfrm>
-            <a:off x="7799832" y="4645152"/>
+            <a:off x="7799832" y="4330598"/>
             <a:ext cx="3145536" cy="256032"/>
           </a:xfrm>
           <a:prstGeom prst="rect">
@@ -3731,8 +3731,8 @@
         </p:nvSpPr>
         <p:spPr>
           <a:xfrm>
-            <a:off x="7799832" y="4974336"/>
-            <a:ext cx="3145536" cy="576072"/>
+            <a:off x="7799832" y="4659782"/>
+            <a:ext cx="3145536" cy="899770"/>
           </a:xfrm>
           <a:prstGeom prst="rect">
             <a:avLst/>
@@ -3758,7 +3758,7 @@
                 <a:ea typeface="Aptos" pitchFamily="34" charset="-122"/>
                 <a:cs typeface="Aptos" pitchFamily="34" charset="-120"/>
               </a:rPr>
-              <a:t>Use the concept to plan transparent communication, gather stakeholder input, protect trust, and make sure affected.</a:t>
+              <a:t>Use the concept to plan transparent communication, gather stakeholder input, protect trust, and make sure affected communities are considered early.</a:t>
             </a:r>
             <a:endParaRPr lang="en-US" sz="1320" dirty="0"/>
           </a:p>
@@ -4127,11 +4127,11 @@
         <p:spPr>
           <a:xfrm>
             <a:off x="7635240" y="1325880"/>
-            <a:ext cx="3474720" cy="1325880"/>
+            <a:ext cx="3474720" cy="1207008"/>
           </a:xfrm>
           <a:prstGeom prst="roundRect">
             <a:avLst>
-              <a:gd name="adj" fmla="val 8276"/>
+              <a:gd name="adj" fmla="val 9091"/>
             </a:avLst>
           </a:prstGeom>
           <a:solidFill>
@@ -4193,7 +4193,7 @@
         <p:spPr>
           <a:xfrm>
             <a:off x="7799832" y="1801368"/>
-            <a:ext cx="3145536" cy="758952"/>
+            <a:ext cx="3145536" cy="640080"/>
           </a:xfrm>
           <a:prstGeom prst="rect">
             <a:avLst/>
@@ -4233,12 +4233,12 @@
         </p:nvSpPr>
         <p:spPr>
           <a:xfrm>
-            <a:off x="7635240" y="2788920"/>
-            <a:ext cx="3474720" cy="1536192"/>
+            <a:off x="7635240" y="2670048"/>
+            <a:ext cx="3474720" cy="1377086"/>
           </a:xfrm>
           <a:prstGeom prst="roundRect">
             <a:avLst>
-              <a:gd name="adj" fmla="val 7143"/>
+              <a:gd name="adj" fmla="val 7968"/>
             </a:avLst>
           </a:prstGeom>
           <a:solidFill>
@@ -4260,8 +4260,8 @@
         </p:nvSpPr>
         <p:spPr>
           <a:xfrm>
-            <a:off x="7799832" y="2935224"/>
-            <a:ext cx="3145536" cy="256032"/>
+            <a:off x="7799832" y="2798064"/>
+            <a:ext cx="3145536" cy="237744"/>
           </a:xfrm>
           <a:prstGeom prst="rect">
             <a:avLst/>
@@ -4277,7 +4277,7 @@
               <a:buNone/>
             </a:pPr>
             <a:r>
-              <a:rPr lang="en-US" sz="1300" b="1" dirty="0">
+              <a:rPr lang="en-US" sz="1250" b="1" dirty="0">
                 <a:solidFill>
                   <a:srgbClr val="0068B7"/>
                 </a:solidFill>
@@ -4285,101 +4285,317 @@
                 <a:ea typeface="Aptos" pitchFamily="34" charset="-122"/>
                 <a:cs typeface="Aptos" pitchFamily="34" charset="-120"/>
               </a:rPr>
-              <a:t>Concept checkpoints</a:t>
-            </a:r>
-            <a:endParaRPr lang="en-US" sz="1300" dirty="0"/>
-          </a:p>
-        </p:txBody>
-      </p:sp>
-      <p:sp>
-        <p:nvSpPr>
-          <p:cNvPr id="15" name="Text 13"/>
-          <p:cNvSpPr/>
-          <p:nvPr/>
-        </p:nvSpPr>
-        <p:spPr>
-          <a:xfrm>
-            <a:off x="7818120" y="3300984"/>
-            <a:ext cx="3090672" cy="877824"/>
-          </a:xfrm>
-          <a:prstGeom prst="rect">
-            <a:avLst/>
-          </a:prstGeom>
-          <a:noFill/>
-          <a:ln/>
-        </p:spPr>
-        <p:txBody>
-          <a:bodyPr wrap="square" lIns="508" tIns="508" rIns="508" bIns="508" rtlCol="0" anchor="t">
+              <a:t>Trust cycle</a:t>
+            </a:r>
+            <a:endParaRPr lang="en-US" sz="1250" dirty="0"/>
+          </a:p>
+        </p:txBody>
+      </p:sp>
+      <p:sp>
+        <p:nvSpPr>
+          <p:cNvPr id="15" name="Shape 13"/>
+          <p:cNvSpPr/>
+          <p:nvPr/>
+        </p:nvSpPr>
+        <p:spPr>
+          <a:xfrm>
+            <a:off x="8763000" y="3351276"/>
+            <a:ext cx="164592" cy="0"/>
+          </a:xfrm>
+          <a:prstGeom prst="line">
+            <a:avLst/>
+          </a:prstGeom>
+          <a:noFill/>
+          <a:ln w="15240">
+            <a:solidFill>
+              <a:srgbClr val="8ABBD8"/>
+            </a:solidFill>
+            <a:prstDash val="solid"/>
+          </a:ln>
+        </p:spPr>
+      </p:sp>
+      <p:sp>
+        <p:nvSpPr>
+          <p:cNvPr id="16" name="Shape 14"/>
+          <p:cNvSpPr/>
+          <p:nvPr/>
+        </p:nvSpPr>
+        <p:spPr>
+          <a:xfrm>
+            <a:off x="7872984" y="3200400"/>
+            <a:ext cx="890016" cy="301752"/>
+          </a:xfrm>
+          <a:prstGeom prst="roundRect">
+            <a:avLst>
+              <a:gd name="adj" fmla="val 24242"/>
+            </a:avLst>
+          </a:prstGeom>
+          <a:solidFill>
+            <a:srgbClr val="0068B7"/>
+          </a:solidFill>
+          <a:ln w="12700">
+            <a:solidFill>
+              <a:srgbClr val="0068B7"/>
+            </a:solidFill>
+            <a:prstDash val="solid"/>
+          </a:ln>
+        </p:spPr>
+      </p:sp>
+      <p:sp>
+        <p:nvSpPr>
+          <p:cNvPr id="17" name="Text 15"/>
+          <p:cNvSpPr/>
+          <p:nvPr/>
+        </p:nvSpPr>
+        <p:spPr>
+          <a:xfrm>
+            <a:off x="7909560" y="3273552"/>
+            <a:ext cx="816864" cy="146304"/>
+          </a:xfrm>
+          <a:prstGeom prst="rect">
+            <a:avLst/>
+          </a:prstGeom>
+          <a:noFill/>
+          <a:ln/>
+        </p:spPr>
+        <p:txBody>
+          <a:bodyPr wrap="square" lIns="0" tIns="0" rIns="0" bIns="0" rtlCol="0" anchor="ctr">
             <a:normAutofit/>
           </a:bodyPr>
           <a:lstStyle/>
           <a:p>
-            <a:pPr indent="0" marL="0">
-              <a:buNone/>
-            </a:pPr>
-            <a:r>
-              <a:rPr lang="en-US" sz="1220" dirty="0">
-                <a:solidFill>
-                  <a:srgbClr val="17364A"/>
-                </a:solidFill>
-                <a:latin typeface="Aptos" pitchFamily="34" charset="0"/>
-                <a:ea typeface="Aptos" pitchFamily="34" charset="-122"/>
-                <a:cs typeface="Aptos" pitchFamily="34" charset="-120"/>
-              </a:rPr>
-              <a:t>Extraction, classification, summarization, translation, topic.</a:t>
-            </a:r>
-            <a:endParaRPr lang="en-US" sz="1220" dirty="0"/>
-          </a:p>
-          <a:p>
-            <a:pPr indent="0" marL="0">
-              <a:buNone/>
-            </a:pPr>
-            <a:r>
-              <a:rPr lang="en-US" sz="1220" dirty="0">
-                <a:solidFill>
-                  <a:srgbClr val="17364A"/>
-                </a:solidFill>
-                <a:latin typeface="Aptos" pitchFamily="34" charset="0"/>
-                <a:ea typeface="Aptos" pitchFamily="34" charset="-122"/>
-                <a:cs typeface="Aptos" pitchFamily="34" charset="-120"/>
-              </a:rPr>
-              <a:t>Staff should define the task narrowly before selecting or testing.</a:t>
-            </a:r>
-            <a:endParaRPr lang="en-US" sz="1220" dirty="0"/>
-          </a:p>
-          <a:p>
-            <a:pPr indent="0" marL="0">
-              <a:buNone/>
-            </a:pPr>
-            <a:r>
-              <a:rPr lang="en-US" sz="1220" dirty="0">
-                <a:solidFill>
-                  <a:srgbClr val="17364A"/>
-                </a:solidFill>
-                <a:latin typeface="Aptos" pitchFamily="34" charset="0"/>
-                <a:ea typeface="Aptos" pitchFamily="34" charset="-122"/>
-                <a:cs typeface="Aptos" pitchFamily="34" charset="-120"/>
-              </a:rPr>
-              <a:t>Evaluation should use representative source text.</a:t>
-            </a:r>
-            <a:endParaRPr lang="en-US" sz="1220" dirty="0"/>
-          </a:p>
-        </p:txBody>
-      </p:sp>
-      <p:sp>
-        <p:nvSpPr>
-          <p:cNvPr id="16" name="Shape 14"/>
-          <p:cNvSpPr/>
-          <p:nvPr/>
-        </p:nvSpPr>
-        <p:spPr>
-          <a:xfrm>
-            <a:off x="7635240" y="4498848"/>
-            <a:ext cx="3474720" cy="1143000"/>
+            <a:pPr algn="ctr" indent="0" marL="0">
+              <a:buNone/>
+            </a:pPr>
+            <a:r>
+              <a:rPr lang="en-US" sz="880" b="1" dirty="0">
+                <a:solidFill>
+                  <a:srgbClr val="FFFFFF"/>
+                </a:solidFill>
+                <a:latin typeface="Aptos" pitchFamily="34" charset="0"/>
+                <a:ea typeface="Aptos" pitchFamily="34" charset="-122"/>
+                <a:cs typeface="Aptos" pitchFamily="34" charset="-120"/>
+              </a:rPr>
+              <a:t>Listen</a:t>
+            </a:r>
+            <a:endParaRPr lang="en-US" sz="880" dirty="0"/>
+          </a:p>
+        </p:txBody>
+      </p:sp>
+      <p:sp>
+        <p:nvSpPr>
+          <p:cNvPr id="18" name="Shape 16"/>
+          <p:cNvSpPr/>
+          <p:nvPr/>
+        </p:nvSpPr>
+        <p:spPr>
+          <a:xfrm>
+            <a:off x="9817608" y="3351276"/>
+            <a:ext cx="164592" cy="0"/>
+          </a:xfrm>
+          <a:prstGeom prst="line">
+            <a:avLst/>
+          </a:prstGeom>
+          <a:noFill/>
+          <a:ln w="15240">
+            <a:solidFill>
+              <a:srgbClr val="8ABBD8"/>
+            </a:solidFill>
+            <a:prstDash val="solid"/>
+          </a:ln>
+        </p:spPr>
+      </p:sp>
+      <p:sp>
+        <p:nvSpPr>
+          <p:cNvPr id="19" name="Shape 17"/>
+          <p:cNvSpPr/>
+          <p:nvPr/>
+        </p:nvSpPr>
+        <p:spPr>
+          <a:xfrm>
+            <a:off x="8927592" y="3200400"/>
+            <a:ext cx="890016" cy="301752"/>
           </a:xfrm>
           <a:prstGeom prst="roundRect">
             <a:avLst>
-              <a:gd name="adj" fmla="val 9600"/>
+              <a:gd name="adj" fmla="val 24242"/>
+            </a:avLst>
+          </a:prstGeom>
+          <a:solidFill>
+            <a:srgbClr val="2F8A28"/>
+          </a:solidFill>
+          <a:ln w="12700">
+            <a:solidFill>
+              <a:srgbClr val="2F8A28"/>
+            </a:solidFill>
+            <a:prstDash val="solid"/>
+          </a:ln>
+        </p:spPr>
+      </p:sp>
+      <p:sp>
+        <p:nvSpPr>
+          <p:cNvPr id="20" name="Text 18"/>
+          <p:cNvSpPr/>
+          <p:nvPr/>
+        </p:nvSpPr>
+        <p:spPr>
+          <a:xfrm>
+            <a:off x="8964168" y="3273552"/>
+            <a:ext cx="816864" cy="146304"/>
+          </a:xfrm>
+          <a:prstGeom prst="rect">
+            <a:avLst/>
+          </a:prstGeom>
+          <a:noFill/>
+          <a:ln/>
+        </p:spPr>
+        <p:txBody>
+          <a:bodyPr wrap="square" lIns="0" tIns="0" rIns="0" bIns="0" rtlCol="0" anchor="ctr">
+            <a:normAutofit/>
+          </a:bodyPr>
+          <a:lstStyle/>
+          <a:p>
+            <a:pPr algn="ctr" indent="0" marL="0">
+              <a:buNone/>
+            </a:pPr>
+            <a:r>
+              <a:rPr lang="en-US" sz="880" b="1" dirty="0">
+                <a:solidFill>
+                  <a:srgbClr val="FFFFFF"/>
+                </a:solidFill>
+                <a:latin typeface="Aptos" pitchFamily="34" charset="0"/>
+                <a:ea typeface="Aptos" pitchFamily="34" charset="-122"/>
+                <a:cs typeface="Aptos" pitchFamily="34" charset="-120"/>
+              </a:rPr>
+              <a:t>Adapt</a:t>
+            </a:r>
+            <a:endParaRPr lang="en-US" sz="880" dirty="0"/>
+          </a:p>
+        </p:txBody>
+      </p:sp>
+      <p:sp>
+        <p:nvSpPr>
+          <p:cNvPr id="21" name="Shape 19"/>
+          <p:cNvSpPr/>
+          <p:nvPr/>
+        </p:nvSpPr>
+        <p:spPr>
+          <a:xfrm>
+            <a:off x="9982200" y="3200400"/>
+            <a:ext cx="890016" cy="301752"/>
+          </a:xfrm>
+          <a:prstGeom prst="roundRect">
+            <a:avLst>
+              <a:gd name="adj" fmla="val 24242"/>
+            </a:avLst>
+          </a:prstGeom>
+          <a:solidFill>
+            <a:srgbClr val="6A4CA3"/>
+          </a:solidFill>
+          <a:ln w="12700">
+            <a:solidFill>
+              <a:srgbClr val="6A4CA3"/>
+            </a:solidFill>
+            <a:prstDash val="solid"/>
+          </a:ln>
+        </p:spPr>
+      </p:sp>
+      <p:sp>
+        <p:nvSpPr>
+          <p:cNvPr id="22" name="Text 20"/>
+          <p:cNvSpPr/>
+          <p:nvPr/>
+        </p:nvSpPr>
+        <p:spPr>
+          <a:xfrm>
+            <a:off x="10018776" y="3273552"/>
+            <a:ext cx="816864" cy="146304"/>
+          </a:xfrm>
+          <a:prstGeom prst="rect">
+            <a:avLst/>
+          </a:prstGeom>
+          <a:noFill/>
+          <a:ln/>
+        </p:spPr>
+        <p:txBody>
+          <a:bodyPr wrap="square" lIns="0" tIns="0" rIns="0" bIns="0" rtlCol="0" anchor="ctr">
+            <a:normAutofit/>
+          </a:bodyPr>
+          <a:lstStyle/>
+          <a:p>
+            <a:pPr algn="ctr" indent="0" marL="0">
+              <a:buNone/>
+            </a:pPr>
+            <a:r>
+              <a:rPr lang="en-US" sz="880" b="1" dirty="0">
+                <a:solidFill>
+                  <a:srgbClr val="FFFFFF"/>
+                </a:solidFill>
+                <a:latin typeface="Aptos" pitchFamily="34" charset="0"/>
+                <a:ea typeface="Aptos" pitchFamily="34" charset="-122"/>
+                <a:cs typeface="Aptos" pitchFamily="34" charset="-120"/>
+              </a:rPr>
+              <a:t>Report</a:t>
+            </a:r>
+            <a:endParaRPr lang="en-US" sz="880" dirty="0"/>
+          </a:p>
+        </p:txBody>
+      </p:sp>
+      <p:sp>
+        <p:nvSpPr>
+          <p:cNvPr id="23" name="Text 21"/>
+          <p:cNvSpPr/>
+          <p:nvPr/>
+        </p:nvSpPr>
+        <p:spPr>
+          <a:xfrm>
+            <a:off x="7854696" y="3694176"/>
+            <a:ext cx="3035808" cy="206654"/>
+          </a:xfrm>
+          <a:prstGeom prst="rect">
+            <a:avLst/>
+          </a:prstGeom>
+          <a:noFill/>
+          <a:ln/>
+        </p:spPr>
+        <p:txBody>
+          <a:bodyPr wrap="square" lIns="254" tIns="254" rIns="254" bIns="254" rtlCol="0" anchor="t">
+            <a:normAutofit/>
+          </a:bodyPr>
+          <a:lstStyle/>
+          <a:p>
+            <a:pPr indent="0" marL="0">
+              <a:buNone/>
+            </a:pPr>
+            <a:r>
+              <a:rPr lang="en-US" sz="1120" dirty="0">
+                <a:solidFill>
+                  <a:srgbClr val="17364A"/>
+                </a:solidFill>
+                <a:latin typeface="Aptos" pitchFamily="34" charset="0"/>
+                <a:ea typeface="Aptos" pitchFamily="34" charset="-122"/>
+                <a:cs typeface="Aptos" pitchFamily="34" charset="-120"/>
+              </a:rPr>
+              <a:t>Communication and engagement are stronger when feedback changes the work and the department reports what.</a:t>
+            </a:r>
+            <a:endParaRPr lang="en-US" sz="1120" dirty="0"/>
+          </a:p>
+        </p:txBody>
+      </p:sp>
+      <p:sp>
+        <p:nvSpPr>
+          <p:cNvPr id="24" name="Shape 22"/>
+          <p:cNvSpPr/>
+          <p:nvPr/>
+        </p:nvSpPr>
+        <p:spPr>
+          <a:xfrm>
+            <a:off x="7635240" y="4184294"/>
+            <a:ext cx="3474720" cy="1466698"/>
+          </a:xfrm>
+          <a:prstGeom prst="roundRect">
+            <a:avLst>
+              <a:gd name="adj" fmla="val 7481"/>
             </a:avLst>
           </a:prstGeom>
           <a:solidFill>
@@ -4395,13 +4611,13 @@
       </p:sp>
       <p:sp>
         <p:nvSpPr>
-          <p:cNvPr id="17" name="Text 15"/>
-          <p:cNvSpPr/>
-          <p:nvPr/>
-        </p:nvSpPr>
-        <p:spPr>
-          <a:xfrm>
-            <a:off x="7799832" y="4645152"/>
+          <p:cNvPr id="25" name="Text 23"/>
+          <p:cNvSpPr/>
+          <p:nvPr/>
+        </p:nvSpPr>
+        <p:spPr>
+          <a:xfrm>
+            <a:off x="7799832" y="4330598"/>
             <a:ext cx="3145536" cy="256032"/>
           </a:xfrm>
           <a:prstGeom prst="rect">
@@ -4434,14 +4650,14 @@
       </p:sp>
       <p:sp>
         <p:nvSpPr>
-          <p:cNvPr id="18" name="Text 16"/>
-          <p:cNvSpPr/>
-          <p:nvPr/>
-        </p:nvSpPr>
-        <p:spPr>
-          <a:xfrm>
-            <a:off x="7799832" y="4974336"/>
-            <a:ext cx="3145536" cy="576072"/>
+          <p:cNvPr id="26" name="Text 24"/>
+          <p:cNvSpPr/>
+          <p:nvPr/>
+        </p:nvSpPr>
+        <p:spPr>
+          <a:xfrm>
+            <a:off x="7799832" y="4659782"/>
+            <a:ext cx="3145536" cy="899770"/>
           </a:xfrm>
           <a:prstGeom prst="rect">
             <a:avLst/>
@@ -4467,7 +4683,7 @@
                 <a:ea typeface="Aptos" pitchFamily="34" charset="-122"/>
                 <a:cs typeface="Aptos" pitchFamily="34" charset="-120"/>
               </a:rPr>
-              <a:t>Use the concept to plan transparent communication, gather stakeholder input, protect trust, and make sure affected.</a:t>
+              <a:t>Use the concept to plan transparent communication, gather stakeholder input, protect trust, and make sure affected communities are considered early.</a:t>
             </a:r>
             <a:endParaRPr lang="en-US" sz="1320" dirty="0"/>
           </a:p>
@@ -4836,11 +5052,11 @@
         <p:spPr>
           <a:xfrm>
             <a:off x="7635240" y="1325880"/>
-            <a:ext cx="3474720" cy="1325880"/>
+            <a:ext cx="3474720" cy="1207008"/>
           </a:xfrm>
           <a:prstGeom prst="roundRect">
             <a:avLst>
-              <a:gd name="adj" fmla="val 8276"/>
+              <a:gd name="adj" fmla="val 9091"/>
             </a:avLst>
           </a:prstGeom>
           <a:solidFill>
@@ -4902,7 +5118,7 @@
         <p:spPr>
           <a:xfrm>
             <a:off x="7799832" y="1801368"/>
-            <a:ext cx="3145536" cy="758952"/>
+            <a:ext cx="3145536" cy="640080"/>
           </a:xfrm>
           <a:prstGeom prst="rect">
             <a:avLst/>
@@ -4942,7 +5158,7 @@
         </p:nvSpPr>
         <p:spPr>
           <a:xfrm>
-            <a:off x="7635240" y="2788920"/>
+            <a:off x="7635240" y="2670048"/>
             <a:ext cx="3474720" cy="1536192"/>
           </a:xfrm>
           <a:prstGeom prst="roundRect">
@@ -4969,7 +5185,7 @@
         </p:nvSpPr>
         <p:spPr>
           <a:xfrm>
-            <a:off x="7799832" y="2935224"/>
+            <a:off x="7799832" y="2816352"/>
             <a:ext cx="3145536" cy="256032"/>
           </a:xfrm>
           <a:prstGeom prst="rect">
@@ -5008,7 +5224,7 @@
         </p:nvSpPr>
         <p:spPr>
           <a:xfrm>
-            <a:off x="7818120" y="3300984"/>
+            <a:off x="7818120" y="3182112"/>
             <a:ext cx="3090672" cy="877824"/>
           </a:xfrm>
           <a:prstGeom prst="rect">
@@ -5083,12 +5299,12 @@
         </p:nvSpPr>
         <p:spPr>
           <a:xfrm>
-            <a:off x="7635240" y="4498848"/>
-            <a:ext cx="3474720" cy="1143000"/>
+            <a:off x="7635240" y="4343400"/>
+            <a:ext cx="3474720" cy="1255471"/>
           </a:xfrm>
           <a:prstGeom prst="roundRect">
             <a:avLst>
-              <a:gd name="adj" fmla="val 9600"/>
+              <a:gd name="adj" fmla="val 8740"/>
             </a:avLst>
           </a:prstGeom>
           <a:solidFill>
@@ -5110,7 +5326,7 @@
         </p:nvSpPr>
         <p:spPr>
           <a:xfrm>
-            <a:off x="7799832" y="4645152"/>
+            <a:off x="7799832" y="4489704"/>
             <a:ext cx="3145536" cy="256032"/>
           </a:xfrm>
           <a:prstGeom prst="rect">
@@ -5149,8 +5365,8 @@
         </p:nvSpPr>
         <p:spPr>
           <a:xfrm>
-            <a:off x="7799832" y="4974336"/>
-            <a:ext cx="3145536" cy="576072"/>
+            <a:off x="7799832" y="4818888"/>
+            <a:ext cx="3145536" cy="688543"/>
           </a:xfrm>
           <a:prstGeom prst="rect">
             <a:avLst/>
@@ -5176,7 +5392,7 @@
                 <a:ea typeface="Aptos" pitchFamily="34" charset="-122"/>
                 <a:cs typeface="Aptos" pitchFamily="34" charset="-120"/>
               </a:rPr>
-              <a:t>Identify what could go wrong, who could be affected, what safeguards are needed, and what evidence should be reviewed.</a:t>
+              <a:t>Identify what could go wrong, who could be affected, what safeguards are needed, and what evidence should be reviewed before use.</a:t>
             </a:r>
             <a:endParaRPr lang="en-US" sz="1320" dirty="0"/>
           </a:p>
@@ -5545,11 +5761,11 @@
         <p:spPr>
           <a:xfrm>
             <a:off x="7635240" y="1325880"/>
-            <a:ext cx="3474720" cy="1325880"/>
+            <a:ext cx="3474720" cy="1207008"/>
           </a:xfrm>
           <a:prstGeom prst="roundRect">
             <a:avLst>
-              <a:gd name="adj" fmla="val 8276"/>
+              <a:gd name="adj" fmla="val 9091"/>
             </a:avLst>
           </a:prstGeom>
           <a:solidFill>
@@ -5611,7 +5827,7 @@
         <p:spPr>
           <a:xfrm>
             <a:off x="7799832" y="1801368"/>
-            <a:ext cx="3145536" cy="758952"/>
+            <a:ext cx="3145536" cy="640080"/>
           </a:xfrm>
           <a:prstGeom prst="rect">
             <a:avLst/>
@@ -5651,7 +5867,7 @@
         </p:nvSpPr>
         <p:spPr>
           <a:xfrm>
-            <a:off x="7635240" y="2788920"/>
+            <a:off x="7635240" y="2670048"/>
             <a:ext cx="3474720" cy="1536192"/>
           </a:xfrm>
           <a:prstGeom prst="roundRect">
@@ -5678,7 +5894,7 @@
         </p:nvSpPr>
         <p:spPr>
           <a:xfrm>
-            <a:off x="7799832" y="2935224"/>
+            <a:off x="7799832" y="2816352"/>
             <a:ext cx="3145536" cy="256032"/>
           </a:xfrm>
           <a:prstGeom prst="rect">
@@ -5717,7 +5933,7 @@
         </p:nvSpPr>
         <p:spPr>
           <a:xfrm>
-            <a:off x="7818120" y="3300984"/>
+            <a:off x="7818120" y="3182112"/>
             <a:ext cx="3090672" cy="877824"/>
           </a:xfrm>
           <a:prstGeom prst="rect">
@@ -5792,12 +6008,12 @@
         </p:nvSpPr>
         <p:spPr>
           <a:xfrm>
-            <a:off x="7635240" y="4498848"/>
-            <a:ext cx="3474720" cy="1143000"/>
+            <a:off x="7635240" y="4343400"/>
+            <a:ext cx="3474720" cy="1255471"/>
           </a:xfrm>
           <a:prstGeom prst="roundRect">
             <a:avLst>
-              <a:gd name="adj" fmla="val 9600"/>
+              <a:gd name="adj" fmla="val 8740"/>
             </a:avLst>
           </a:prstGeom>
           <a:solidFill>
@@ -5819,7 +6035,7 @@
         </p:nvSpPr>
         <p:spPr>
           <a:xfrm>
-            <a:off x="7799832" y="4645152"/>
+            <a:off x="7799832" y="4489704"/>
             <a:ext cx="3145536" cy="256032"/>
           </a:xfrm>
           <a:prstGeom prst="rect">
@@ -5858,8 +6074,8 @@
         </p:nvSpPr>
         <p:spPr>
           <a:xfrm>
-            <a:off x="7799832" y="4974336"/>
-            <a:ext cx="3145536" cy="576072"/>
+            <a:off x="7799832" y="4818888"/>
+            <a:ext cx="3145536" cy="688543"/>
           </a:xfrm>
           <a:prstGeom prst="rect">
             <a:avLst/>
@@ -5885,7 +6101,7 @@
                 <a:ea typeface="Aptos" pitchFamily="34" charset="-122"/>
                 <a:cs typeface="Aptos" pitchFamily="34" charset="-120"/>
               </a:rPr>
-              <a:t>Identify what could go wrong, who could be affected, what safeguards are needed, and what evidence should be reviewed.</a:t>
+              <a:t>Identify what could go wrong, who could be affected, what safeguards are needed, and what evidence should be reviewed before use.</a:t>
             </a:r>
             <a:endParaRPr lang="en-US" sz="1320" dirty="0"/>
           </a:p>
@@ -6254,11 +6470,11 @@
         <p:spPr>
           <a:xfrm>
             <a:off x="7635240" y="1325880"/>
-            <a:ext cx="3474720" cy="1325880"/>
+            <a:ext cx="3474720" cy="1255471"/>
           </a:xfrm>
           <a:prstGeom prst="roundRect">
             <a:avLst>
-              <a:gd name="adj" fmla="val 8276"/>
+              <a:gd name="adj" fmla="val 8740"/>
             </a:avLst>
           </a:prstGeom>
           <a:solidFill>
@@ -6320,7 +6536,7 @@
         <p:spPr>
           <a:xfrm>
             <a:off x="7799832" y="1801368"/>
-            <a:ext cx="3145536" cy="758952"/>
+            <a:ext cx="3145536" cy="688543"/>
           </a:xfrm>
           <a:prstGeom prst="rect">
             <a:avLst/>
@@ -6360,12 +6576,12 @@
         </p:nvSpPr>
         <p:spPr>
           <a:xfrm>
-            <a:off x="7635240" y="2788920"/>
-            <a:ext cx="3474720" cy="1536192"/>
+            <a:off x="7635240" y="2718511"/>
+            <a:ext cx="3474720" cy="1328623"/>
           </a:xfrm>
           <a:prstGeom prst="roundRect">
             <a:avLst>
-              <a:gd name="adj" fmla="val 7143"/>
+              <a:gd name="adj" fmla="val 8259"/>
             </a:avLst>
           </a:prstGeom>
           <a:solidFill>
@@ -6387,7 +6603,7 @@
         </p:nvSpPr>
         <p:spPr>
           <a:xfrm>
-            <a:off x="7799832" y="2935224"/>
+            <a:off x="7799832" y="2864815"/>
             <a:ext cx="3145536" cy="256032"/>
           </a:xfrm>
           <a:prstGeom prst="rect">
@@ -6426,8 +6642,8 @@
         </p:nvSpPr>
         <p:spPr>
           <a:xfrm>
-            <a:off x="7818120" y="3300984"/>
-            <a:ext cx="3090672" cy="877824"/>
+            <a:off x="7818120" y="3230575"/>
+            <a:ext cx="3090672" cy="670255"/>
           </a:xfrm>
           <a:prstGeom prst="rect">
             <a:avLst/>
@@ -6501,12 +6717,12 @@
         </p:nvSpPr>
         <p:spPr>
           <a:xfrm>
-            <a:off x="7635240" y="4498848"/>
-            <a:ext cx="3474720" cy="1143000"/>
+            <a:off x="7635240" y="4184294"/>
+            <a:ext cx="3474720" cy="1466698"/>
           </a:xfrm>
           <a:prstGeom prst="roundRect">
             <a:avLst>
-              <a:gd name="adj" fmla="val 9600"/>
+              <a:gd name="adj" fmla="val 7481"/>
             </a:avLst>
           </a:prstGeom>
           <a:solidFill>
@@ -6528,7 +6744,7 @@
         </p:nvSpPr>
         <p:spPr>
           <a:xfrm>
-            <a:off x="7799832" y="4645152"/>
+            <a:off x="7799832" y="4330598"/>
             <a:ext cx="3145536" cy="256032"/>
           </a:xfrm>
           <a:prstGeom prst="rect">
@@ -6567,8 +6783,8 @@
         </p:nvSpPr>
         <p:spPr>
           <a:xfrm>
-            <a:off x="7799832" y="4974336"/>
-            <a:ext cx="3145536" cy="576072"/>
+            <a:off x="7799832" y="4659782"/>
+            <a:ext cx="3145536" cy="899770"/>
           </a:xfrm>
           <a:prstGeom prst="rect">
             <a:avLst/>
@@ -6594,7 +6810,7 @@
                 <a:ea typeface="Aptos" pitchFamily="34" charset="-122"/>
                 <a:cs typeface="Aptos" pitchFamily="34" charset="-120"/>
               </a:rPr>
-              <a:t>Use the concept to clarify workflow changes, dependencies, staffing, procurement requirements, training needs, and.</a:t>
+              <a:t>Use the concept to clarify workflow changes, dependencies, staffing, procurement requirements, training needs, and implementation checkpoints.</a:t>
             </a:r>
             <a:endParaRPr lang="en-US" sz="1320" dirty="0"/>
           </a:p>
@@ -6963,11 +7179,11 @@
         <p:spPr>
           <a:xfrm>
             <a:off x="7635240" y="1325880"/>
-            <a:ext cx="3474720" cy="1325880"/>
+            <a:ext cx="3474720" cy="1207008"/>
           </a:xfrm>
           <a:prstGeom prst="roundRect">
             <a:avLst>
-              <a:gd name="adj" fmla="val 8276"/>
+              <a:gd name="adj" fmla="val 9091"/>
             </a:avLst>
           </a:prstGeom>
           <a:solidFill>
@@ -7029,7 +7245,7 @@
         <p:spPr>
           <a:xfrm>
             <a:off x="7799832" y="1801368"/>
-            <a:ext cx="3145536" cy="758952"/>
+            <a:ext cx="3145536" cy="640080"/>
           </a:xfrm>
           <a:prstGeom prst="rect">
             <a:avLst/>
@@ -7069,12 +7285,12 @@
         </p:nvSpPr>
         <p:spPr>
           <a:xfrm>
-            <a:off x="7635240" y="2788920"/>
-            <a:ext cx="3474720" cy="1536192"/>
+            <a:off x="7635240" y="2670048"/>
+            <a:ext cx="3474720" cy="1377086"/>
           </a:xfrm>
           <a:prstGeom prst="roundRect">
             <a:avLst>
-              <a:gd name="adj" fmla="val 7143"/>
+              <a:gd name="adj" fmla="val 7968"/>
             </a:avLst>
           </a:prstGeom>
           <a:solidFill>
@@ -7096,7 +7312,7 @@
         </p:nvSpPr>
         <p:spPr>
           <a:xfrm>
-            <a:off x="7799832" y="2935224"/>
+            <a:off x="7799832" y="2816352"/>
             <a:ext cx="3145536" cy="256032"/>
           </a:xfrm>
           <a:prstGeom prst="rect">
@@ -7135,8 +7351,8 @@
         </p:nvSpPr>
         <p:spPr>
           <a:xfrm>
-            <a:off x="7818120" y="3300984"/>
-            <a:ext cx="3090672" cy="877824"/>
+            <a:off x="7818120" y="3182112"/>
+            <a:ext cx="3090672" cy="718718"/>
           </a:xfrm>
           <a:prstGeom prst="rect">
             <a:avLst/>
@@ -7210,12 +7426,12 @@
         </p:nvSpPr>
         <p:spPr>
           <a:xfrm>
-            <a:off x="7635240" y="4498848"/>
-            <a:ext cx="3474720" cy="1143000"/>
+            <a:off x="7635240" y="4184294"/>
+            <a:ext cx="3474720" cy="1466698"/>
           </a:xfrm>
           <a:prstGeom prst="roundRect">
             <a:avLst>
-              <a:gd name="adj" fmla="val 9600"/>
+              <a:gd name="adj" fmla="val 7481"/>
             </a:avLst>
           </a:prstGeom>
           <a:solidFill>
@@ -7237,7 +7453,7 @@
         </p:nvSpPr>
         <p:spPr>
           <a:xfrm>
-            <a:off x="7799832" y="4645152"/>
+            <a:off x="7799832" y="4330598"/>
             <a:ext cx="3145536" cy="256032"/>
           </a:xfrm>
           <a:prstGeom prst="rect">
@@ -7276,8 +7492,8 @@
         </p:nvSpPr>
         <p:spPr>
           <a:xfrm>
-            <a:off x="7799832" y="4974336"/>
-            <a:ext cx="3145536" cy="576072"/>
+            <a:off x="7799832" y="4659782"/>
+            <a:ext cx="3145536" cy="899770"/>
           </a:xfrm>
           <a:prstGeom prst="rect">
             <a:avLst/>
@@ -7303,7 +7519,7 @@
                 <a:ea typeface="Aptos" pitchFamily="34" charset="-122"/>
                 <a:cs typeface="Aptos" pitchFamily="34" charset="-120"/>
               </a:rPr>
-              <a:t>Use the concept to plan transparent communication, gather stakeholder input, protect trust, and make sure affected.</a:t>
+              <a:t>Use the concept to plan transparent communication, gather stakeholder input, protect trust, and make sure affected communities are considered early.</a:t>
             </a:r>
             <a:endParaRPr lang="en-US" sz="1320" dirty="0"/>
           </a:p>
@@ -7655,11 +7871,11 @@
         <p:spPr>
           <a:xfrm>
             <a:off x="7635240" y="1325880"/>
-            <a:ext cx="3474720" cy="1325880"/>
+            <a:ext cx="3474720" cy="1207008"/>
           </a:xfrm>
           <a:prstGeom prst="roundRect">
             <a:avLst>
-              <a:gd name="adj" fmla="val 8276"/>
+              <a:gd name="adj" fmla="val 9091"/>
             </a:avLst>
           </a:prstGeom>
           <a:solidFill>
@@ -7721,7 +7937,7 @@
         <p:spPr>
           <a:xfrm>
             <a:off x="7799832" y="1801368"/>
-            <a:ext cx="3145536" cy="758952"/>
+            <a:ext cx="3145536" cy="640080"/>
           </a:xfrm>
           <a:prstGeom prst="rect">
             <a:avLst/>
@@ -7761,12 +7977,12 @@
         </p:nvSpPr>
         <p:spPr>
           <a:xfrm>
-            <a:off x="7635240" y="2788920"/>
-            <a:ext cx="3474720" cy="1536192"/>
+            <a:off x="7635240" y="2670048"/>
+            <a:ext cx="3474720" cy="1377086"/>
           </a:xfrm>
           <a:prstGeom prst="roundRect">
             <a:avLst>
-              <a:gd name="adj" fmla="val 7143"/>
+              <a:gd name="adj" fmla="val 7968"/>
             </a:avLst>
           </a:prstGeom>
           <a:solidFill>
@@ -7788,7 +8004,7 @@
         </p:nvSpPr>
         <p:spPr>
           <a:xfrm>
-            <a:off x="7799832" y="2935224"/>
+            <a:off x="7799832" y="2816352"/>
             <a:ext cx="3145536" cy="256032"/>
           </a:xfrm>
           <a:prstGeom prst="rect">
@@ -7827,8 +8043,8 @@
         </p:nvSpPr>
         <p:spPr>
           <a:xfrm>
-            <a:off x="7818120" y="3300984"/>
-            <a:ext cx="3090672" cy="877824"/>
+            <a:off x="7818120" y="3182112"/>
+            <a:ext cx="3090672" cy="718718"/>
           </a:xfrm>
           <a:prstGeom prst="rect">
             <a:avLst/>
@@ -7885,12 +8101,12 @@
         </p:nvSpPr>
         <p:spPr>
           <a:xfrm>
-            <a:off x="7635240" y="4498848"/>
-            <a:ext cx="3474720" cy="1143000"/>
+            <a:off x="7635240" y="4184294"/>
+            <a:ext cx="3474720" cy="1466698"/>
           </a:xfrm>
           <a:prstGeom prst="roundRect">
             <a:avLst>
-              <a:gd name="adj" fmla="val 9600"/>
+              <a:gd name="adj" fmla="val 7481"/>
             </a:avLst>
           </a:prstGeom>
           <a:solidFill>
@@ -7912,7 +8128,7 @@
         </p:nvSpPr>
         <p:spPr>
           <a:xfrm>
-            <a:off x="7799832" y="4645152"/>
+            <a:off x="7799832" y="4330598"/>
             <a:ext cx="3145536" cy="256032"/>
           </a:xfrm>
           <a:prstGeom prst="rect">
@@ -7951,8 +8167,8 @@
         </p:nvSpPr>
         <p:spPr>
           <a:xfrm>
-            <a:off x="7799832" y="4974336"/>
-            <a:ext cx="3145536" cy="576072"/>
+            <a:off x="7799832" y="4659782"/>
+            <a:ext cx="3145536" cy="899770"/>
           </a:xfrm>
           <a:prstGeom prst="rect">
             <a:avLst/>
@@ -7978,7 +8194,7 @@
                 <a:ea typeface="Aptos" pitchFamily="34" charset="-122"/>
                 <a:cs typeface="Aptos" pitchFamily="34" charset="-120"/>
               </a:rPr>
-              <a:t>Use the concept to plan transparent communication, gather stakeholder input, protect trust, and make sure affected.</a:t>
+              <a:t>Use the concept to plan transparent communication, gather stakeholder input, protect trust, and make sure affected communities are considered early.</a:t>
             </a:r>
             <a:endParaRPr lang="en-US" sz="1320" dirty="0"/>
           </a:p>
@@ -8330,11 +8546,11 @@
         <p:spPr>
           <a:xfrm>
             <a:off x="7635240" y="1325880"/>
-            <a:ext cx="3474720" cy="1325880"/>
+            <a:ext cx="3474720" cy="1207008"/>
           </a:xfrm>
           <a:prstGeom prst="roundRect">
             <a:avLst>
-              <a:gd name="adj" fmla="val 8276"/>
+              <a:gd name="adj" fmla="val 9091"/>
             </a:avLst>
           </a:prstGeom>
           <a:solidFill>
@@ -8396,7 +8612,7 @@
         <p:spPr>
           <a:xfrm>
             <a:off x="7799832" y="1801368"/>
-            <a:ext cx="3145536" cy="758952"/>
+            <a:ext cx="3145536" cy="640080"/>
           </a:xfrm>
           <a:prstGeom prst="rect">
             <a:avLst/>
@@ -8436,12 +8652,12 @@
         </p:nvSpPr>
         <p:spPr>
           <a:xfrm>
-            <a:off x="7635240" y="2788920"/>
-            <a:ext cx="3474720" cy="1536192"/>
+            <a:off x="7635240" y="2670048"/>
+            <a:ext cx="3474720" cy="1377086"/>
           </a:xfrm>
           <a:prstGeom prst="roundRect">
             <a:avLst>
-              <a:gd name="adj" fmla="val 7143"/>
+              <a:gd name="adj" fmla="val 7968"/>
             </a:avLst>
           </a:prstGeom>
           <a:solidFill>
@@ -8463,7 +8679,7 @@
         </p:nvSpPr>
         <p:spPr>
           <a:xfrm>
-            <a:off x="7799832" y="2935224"/>
+            <a:off x="7799832" y="2816352"/>
             <a:ext cx="3145536" cy="256032"/>
           </a:xfrm>
           <a:prstGeom prst="rect">
@@ -8502,8 +8718,8 @@
         </p:nvSpPr>
         <p:spPr>
           <a:xfrm>
-            <a:off x="7818120" y="3300984"/>
-            <a:ext cx="3090672" cy="877824"/>
+            <a:off x="7818120" y="3182112"/>
+            <a:ext cx="3090672" cy="718718"/>
           </a:xfrm>
           <a:prstGeom prst="rect">
             <a:avLst/>
@@ -8560,12 +8776,12 @@
         </p:nvSpPr>
         <p:spPr>
           <a:xfrm>
-            <a:off x="7635240" y="4498848"/>
-            <a:ext cx="3474720" cy="1143000"/>
+            <a:off x="7635240" y="4184294"/>
+            <a:ext cx="3474720" cy="1466698"/>
           </a:xfrm>
           <a:prstGeom prst="roundRect">
             <a:avLst>
-              <a:gd name="adj" fmla="val 9600"/>
+              <a:gd name="adj" fmla="val 7481"/>
             </a:avLst>
           </a:prstGeom>
           <a:solidFill>
@@ -8587,7 +8803,7 @@
         </p:nvSpPr>
         <p:spPr>
           <a:xfrm>
-            <a:off x="7799832" y="4645152"/>
+            <a:off x="7799832" y="4330598"/>
             <a:ext cx="3145536" cy="256032"/>
           </a:xfrm>
           <a:prstGeom prst="rect">
@@ -8626,8 +8842,8 @@
         </p:nvSpPr>
         <p:spPr>
           <a:xfrm>
-            <a:off x="7799832" y="4974336"/>
-            <a:ext cx="3145536" cy="576072"/>
+            <a:off x="7799832" y="4659782"/>
+            <a:ext cx="3145536" cy="899770"/>
           </a:xfrm>
           <a:prstGeom prst="rect">
             <a:avLst/>
@@ -8653,7 +8869,7 @@
                 <a:ea typeface="Aptos" pitchFamily="34" charset="-122"/>
                 <a:cs typeface="Aptos" pitchFamily="34" charset="-120"/>
               </a:rPr>
-              <a:t>Use the assignment to test whether you can explain the concept, apply it to a realistic public health situation, and.</a:t>
+              <a:t>Use the assignment to test whether you can explain the concept, apply it to a realistic public health situation, and identify what would need review before the work moves forward.</a:t>
             </a:r>
             <a:endParaRPr lang="en-US" sz="1320" dirty="0"/>
           </a:p>
@@ -9022,11 +9238,11 @@
         <p:spPr>
           <a:xfrm>
             <a:off x="7635240" y="1325880"/>
-            <a:ext cx="3474720" cy="1325880"/>
+            <a:ext cx="3474720" cy="1207008"/>
           </a:xfrm>
           <a:prstGeom prst="roundRect">
             <a:avLst>
-              <a:gd name="adj" fmla="val 8276"/>
+              <a:gd name="adj" fmla="val 9091"/>
             </a:avLst>
           </a:prstGeom>
           <a:solidFill>
@@ -9088,7 +9304,7 @@
         <p:spPr>
           <a:xfrm>
             <a:off x="7799832" y="1801368"/>
-            <a:ext cx="3145536" cy="758952"/>
+            <a:ext cx="3145536" cy="640080"/>
           </a:xfrm>
           <a:prstGeom prst="rect">
             <a:avLst/>
@@ -9128,12 +9344,12 @@
         </p:nvSpPr>
         <p:spPr>
           <a:xfrm>
-            <a:off x="7635240" y="2788920"/>
-            <a:ext cx="3474720" cy="1536192"/>
+            <a:off x="7635240" y="2670048"/>
+            <a:ext cx="3474720" cy="1377086"/>
           </a:xfrm>
           <a:prstGeom prst="roundRect">
             <a:avLst>
-              <a:gd name="adj" fmla="val 7143"/>
+              <a:gd name="adj" fmla="val 7968"/>
             </a:avLst>
           </a:prstGeom>
           <a:solidFill>
@@ -9155,7 +9371,7 @@
         </p:nvSpPr>
         <p:spPr>
           <a:xfrm>
-            <a:off x="7799832" y="2935224"/>
+            <a:off x="7799832" y="2816352"/>
             <a:ext cx="3145536" cy="256032"/>
           </a:xfrm>
           <a:prstGeom prst="rect">
@@ -9194,8 +9410,8 @@
         </p:nvSpPr>
         <p:spPr>
           <a:xfrm>
-            <a:off x="7818120" y="3300984"/>
-            <a:ext cx="3090672" cy="877824"/>
+            <a:off x="7818120" y="3182112"/>
+            <a:ext cx="3090672" cy="718718"/>
           </a:xfrm>
           <a:prstGeom prst="rect">
             <a:avLst/>
@@ -9269,12 +9485,12 @@
         </p:nvSpPr>
         <p:spPr>
           <a:xfrm>
-            <a:off x="7635240" y="4498848"/>
-            <a:ext cx="3474720" cy="1143000"/>
+            <a:off x="7635240" y="4184294"/>
+            <a:ext cx="3474720" cy="1466698"/>
           </a:xfrm>
           <a:prstGeom prst="roundRect">
             <a:avLst>
-              <a:gd name="adj" fmla="val 9600"/>
+              <a:gd name="adj" fmla="val 7481"/>
             </a:avLst>
           </a:prstGeom>
           <a:solidFill>
@@ -9296,7 +9512,7 @@
         </p:nvSpPr>
         <p:spPr>
           <a:xfrm>
-            <a:off x="7799832" y="4645152"/>
+            <a:off x="7799832" y="4330598"/>
             <a:ext cx="3145536" cy="256032"/>
           </a:xfrm>
           <a:prstGeom prst="rect">
@@ -9335,8 +9551,8 @@
         </p:nvSpPr>
         <p:spPr>
           <a:xfrm>
-            <a:off x="7799832" y="4974336"/>
-            <a:ext cx="3145536" cy="576072"/>
+            <a:off x="7799832" y="4659782"/>
+            <a:ext cx="3145536" cy="899770"/>
           </a:xfrm>
           <a:prstGeom prst="rect">
             <a:avLst/>
@@ -9362,7 +9578,7 @@
                 <a:ea typeface="Aptos" pitchFamily="34" charset="-122"/>
                 <a:cs typeface="Aptos" pitchFamily="34" charset="-120"/>
               </a:rPr>
-              <a:t>Use the concept to plan transparent communication, gather stakeholder input, protect trust, and make sure affected.</a:t>
+              <a:t>Use the concept to plan transparent communication, gather stakeholder input, protect trust, and make sure affected communities are considered early.</a:t>
             </a:r>
             <a:endParaRPr lang="en-US" sz="1320" dirty="0"/>
           </a:p>
@@ -9697,11 +9913,11 @@
         <p:spPr>
           <a:xfrm>
             <a:off x="7635240" y="1325880"/>
-            <a:ext cx="3474720" cy="1325880"/>
+            <a:ext cx="3474720" cy="1207008"/>
           </a:xfrm>
           <a:prstGeom prst="roundRect">
             <a:avLst>
-              <a:gd name="adj" fmla="val 8276"/>
+              <a:gd name="adj" fmla="val 9091"/>
             </a:avLst>
           </a:prstGeom>
           <a:solidFill>
@@ -9763,7 +9979,7 @@
         <p:spPr>
           <a:xfrm>
             <a:off x="7799832" y="1801368"/>
-            <a:ext cx="3145536" cy="758952"/>
+            <a:ext cx="3145536" cy="640080"/>
           </a:xfrm>
           <a:prstGeom prst="rect">
             <a:avLst/>
@@ -9803,12 +10019,12 @@
         </p:nvSpPr>
         <p:spPr>
           <a:xfrm>
-            <a:off x="7635240" y="2788920"/>
-            <a:ext cx="3474720" cy="1536192"/>
+            <a:off x="7635240" y="2670048"/>
+            <a:ext cx="3474720" cy="1377086"/>
           </a:xfrm>
           <a:prstGeom prst="roundRect">
             <a:avLst>
-              <a:gd name="adj" fmla="val 7143"/>
+              <a:gd name="adj" fmla="val 7968"/>
             </a:avLst>
           </a:prstGeom>
           <a:solidFill>
@@ -9830,7 +10046,7 @@
         </p:nvSpPr>
         <p:spPr>
           <a:xfrm>
-            <a:off x="7799832" y="2935224"/>
+            <a:off x="7799832" y="2816352"/>
             <a:ext cx="3145536" cy="256032"/>
           </a:xfrm>
           <a:prstGeom prst="rect">
@@ -9869,8 +10085,8 @@
         </p:nvSpPr>
         <p:spPr>
           <a:xfrm>
-            <a:off x="7818120" y="3300984"/>
-            <a:ext cx="3090672" cy="877824"/>
+            <a:off x="7818120" y="3182112"/>
+            <a:ext cx="3090672" cy="718718"/>
           </a:xfrm>
           <a:prstGeom prst="rect">
             <a:avLst/>
@@ -9910,12 +10126,12 @@
         </p:nvSpPr>
         <p:spPr>
           <a:xfrm>
-            <a:off x="7635240" y="4498848"/>
-            <a:ext cx="3474720" cy="1143000"/>
+            <a:off x="7635240" y="4184294"/>
+            <a:ext cx="3474720" cy="1466698"/>
           </a:xfrm>
           <a:prstGeom prst="roundRect">
             <a:avLst>
-              <a:gd name="adj" fmla="val 9600"/>
+              <a:gd name="adj" fmla="val 7481"/>
             </a:avLst>
           </a:prstGeom>
           <a:solidFill>
@@ -9937,7 +10153,7 @@
         </p:nvSpPr>
         <p:spPr>
           <a:xfrm>
-            <a:off x="7799832" y="4645152"/>
+            <a:off x="7799832" y="4330598"/>
             <a:ext cx="3145536" cy="256032"/>
           </a:xfrm>
           <a:prstGeom prst="rect">
@@ -9976,8 +10192,8 @@
         </p:nvSpPr>
         <p:spPr>
           <a:xfrm>
-            <a:off x="7799832" y="4974336"/>
-            <a:ext cx="3145536" cy="576072"/>
+            <a:off x="7799832" y="4659782"/>
+            <a:ext cx="3145536" cy="899770"/>
           </a:xfrm>
           <a:prstGeom prst="rect">
             <a:avLst/>
@@ -10003,7 +10219,7 @@
                 <a:ea typeface="Aptos" pitchFamily="34" charset="-122"/>
                 <a:cs typeface="Aptos" pitchFamily="34" charset="-120"/>
               </a:rPr>
-              <a:t>Use the concept to plan transparent communication, gather stakeholder input, protect trust, and make sure affected.</a:t>
+              <a:t>Use the concept to plan transparent communication, gather stakeholder input, protect trust, and make sure affected communities are considered early.</a:t>
             </a:r>
             <a:endParaRPr lang="en-US" sz="1320" dirty="0"/>
           </a:p>
@@ -10974,11 +11190,11 @@
         <p:spPr>
           <a:xfrm>
             <a:off x="7635240" y="1325880"/>
-            <a:ext cx="3474720" cy="1325880"/>
+            <a:ext cx="3474720" cy="1207008"/>
           </a:xfrm>
           <a:prstGeom prst="roundRect">
             <a:avLst>
-              <a:gd name="adj" fmla="val 8276"/>
+              <a:gd name="adj" fmla="val 9091"/>
             </a:avLst>
           </a:prstGeom>
           <a:solidFill>
@@ -11040,7 +11256,7 @@
         <p:spPr>
           <a:xfrm>
             <a:off x="7799832" y="1801368"/>
-            <a:ext cx="3145536" cy="758952"/>
+            <a:ext cx="3145536" cy="640080"/>
           </a:xfrm>
           <a:prstGeom prst="rect">
             <a:avLst/>
@@ -11080,12 +11296,12 @@
         </p:nvSpPr>
         <p:spPr>
           <a:xfrm>
-            <a:off x="7635240" y="2788920"/>
-            <a:ext cx="3474720" cy="1536192"/>
+            <a:off x="7635240" y="2670048"/>
+            <a:ext cx="3474720" cy="1377086"/>
           </a:xfrm>
           <a:prstGeom prst="roundRect">
             <a:avLst>
-              <a:gd name="adj" fmla="val 7143"/>
+              <a:gd name="adj" fmla="val 7968"/>
             </a:avLst>
           </a:prstGeom>
           <a:solidFill>
@@ -11107,7 +11323,7 @@
         </p:nvSpPr>
         <p:spPr>
           <a:xfrm>
-            <a:off x="7799832" y="2935224"/>
+            <a:off x="7799832" y="2816352"/>
             <a:ext cx="3145536" cy="256032"/>
           </a:xfrm>
           <a:prstGeom prst="rect">
@@ -11146,8 +11362,8 @@
         </p:nvSpPr>
         <p:spPr>
           <a:xfrm>
-            <a:off x="7818120" y="3300984"/>
-            <a:ext cx="3090672" cy="877824"/>
+            <a:off x="7818120" y="3182112"/>
+            <a:ext cx="3090672" cy="718718"/>
           </a:xfrm>
           <a:prstGeom prst="rect">
             <a:avLst/>
@@ -11221,12 +11437,12 @@
         </p:nvSpPr>
         <p:spPr>
           <a:xfrm>
-            <a:off x="7635240" y="4498848"/>
-            <a:ext cx="3474720" cy="1143000"/>
+            <a:off x="7635240" y="4184294"/>
+            <a:ext cx="3474720" cy="1466698"/>
           </a:xfrm>
           <a:prstGeom prst="roundRect">
             <a:avLst>
-              <a:gd name="adj" fmla="val 9600"/>
+              <a:gd name="adj" fmla="val 7481"/>
             </a:avLst>
           </a:prstGeom>
           <a:solidFill>
@@ -11248,7 +11464,7 @@
         </p:nvSpPr>
         <p:spPr>
           <a:xfrm>
-            <a:off x="7799832" y="4645152"/>
+            <a:off x="7799832" y="4330598"/>
             <a:ext cx="3145536" cy="256032"/>
           </a:xfrm>
           <a:prstGeom prst="rect">
@@ -11287,8 +11503,8 @@
         </p:nvSpPr>
         <p:spPr>
           <a:xfrm>
-            <a:off x="7799832" y="4974336"/>
-            <a:ext cx="3145536" cy="576072"/>
+            <a:off x="7799832" y="4659782"/>
+            <a:ext cx="3145536" cy="899770"/>
           </a:xfrm>
           <a:prstGeom prst="rect">
             <a:avLst/>
@@ -11314,7 +11530,7 @@
                 <a:ea typeface="Aptos" pitchFamily="34" charset="-122"/>
                 <a:cs typeface="Aptos" pitchFamily="34" charset="-120"/>
               </a:rPr>
-              <a:t>Use the assignment to test whether you can explain the concept, apply it to a realistic public health situation, and.</a:t>
+              <a:t>Use the assignment to test whether you can explain the concept, apply it to a realistic public health situation, and identify what would need review before the work moves forward.</a:t>
             </a:r>
             <a:endParaRPr lang="en-US" sz="1320" dirty="0"/>
           </a:p>
@@ -11683,11 +11899,11 @@
         <p:spPr>
           <a:xfrm>
             <a:off x="7635240" y="1325880"/>
-            <a:ext cx="3474720" cy="1325880"/>
+            <a:ext cx="3474720" cy="1207008"/>
           </a:xfrm>
           <a:prstGeom prst="roundRect">
             <a:avLst>
-              <a:gd name="adj" fmla="val 8276"/>
+              <a:gd name="adj" fmla="val 9091"/>
             </a:avLst>
           </a:prstGeom>
           <a:solidFill>
@@ -11749,7 +11965,7 @@
         <p:spPr>
           <a:xfrm>
             <a:off x="7799832" y="1801368"/>
-            <a:ext cx="3145536" cy="758952"/>
+            <a:ext cx="3145536" cy="640080"/>
           </a:xfrm>
           <a:prstGeom prst="rect">
             <a:avLst/>
@@ -11789,12 +12005,12 @@
         </p:nvSpPr>
         <p:spPr>
           <a:xfrm>
-            <a:off x="7635240" y="2788920"/>
-            <a:ext cx="3474720" cy="1536192"/>
+            <a:off x="7635240" y="2670048"/>
+            <a:ext cx="3474720" cy="1377086"/>
           </a:xfrm>
           <a:prstGeom prst="roundRect">
             <a:avLst>
-              <a:gd name="adj" fmla="val 7143"/>
+              <a:gd name="adj" fmla="val 7968"/>
             </a:avLst>
           </a:prstGeom>
           <a:solidFill>
@@ -11816,7 +12032,7 @@
         </p:nvSpPr>
         <p:spPr>
           <a:xfrm>
-            <a:off x="7799832" y="2935224"/>
+            <a:off x="7799832" y="2816352"/>
             <a:ext cx="3145536" cy="256032"/>
           </a:xfrm>
           <a:prstGeom prst="rect">
@@ -11855,8 +12071,8 @@
         </p:nvSpPr>
         <p:spPr>
           <a:xfrm>
-            <a:off x="7818120" y="3300984"/>
-            <a:ext cx="3090672" cy="877824"/>
+            <a:off x="7818120" y="3182112"/>
+            <a:ext cx="3090672" cy="718718"/>
           </a:xfrm>
           <a:prstGeom prst="rect">
             <a:avLst/>
@@ -11930,12 +12146,12 @@
         </p:nvSpPr>
         <p:spPr>
           <a:xfrm>
-            <a:off x="7635240" y="4498848"/>
-            <a:ext cx="3474720" cy="1143000"/>
+            <a:off x="7635240" y="4184294"/>
+            <a:ext cx="3474720" cy="1466698"/>
           </a:xfrm>
           <a:prstGeom prst="roundRect">
             <a:avLst>
-              <a:gd name="adj" fmla="val 9600"/>
+              <a:gd name="adj" fmla="val 7481"/>
             </a:avLst>
           </a:prstGeom>
           <a:solidFill>
@@ -11957,7 +12173,7 @@
         </p:nvSpPr>
         <p:spPr>
           <a:xfrm>
-            <a:off x="7799832" y="4645152"/>
+            <a:off x="7799832" y="4330598"/>
             <a:ext cx="3145536" cy="256032"/>
           </a:xfrm>
           <a:prstGeom prst="rect">
@@ -11996,8 +12212,8 @@
         </p:nvSpPr>
         <p:spPr>
           <a:xfrm>
-            <a:off x="7799832" y="4974336"/>
-            <a:ext cx="3145536" cy="576072"/>
+            <a:off x="7799832" y="4659782"/>
+            <a:ext cx="3145536" cy="899770"/>
           </a:xfrm>
           <a:prstGeom prst="rect">
             <a:avLst/>
@@ -12023,7 +12239,7 @@
                 <a:ea typeface="Aptos" pitchFamily="34" charset="-122"/>
                 <a:cs typeface="Aptos" pitchFamily="34" charset="-120"/>
               </a:rPr>
-              <a:t>Use the assignment to test whether you can explain the concept, apply it to a realistic public health situation, and.</a:t>
+              <a:t>Use the assignment to test whether you can explain the concept, apply it to a realistic public health situation, and identify what would need review before the work moves forward.</a:t>
             </a:r>
             <a:endParaRPr lang="en-US" sz="1320" dirty="0"/>
           </a:p>
@@ -12392,11 +12608,11 @@
         <p:spPr>
           <a:xfrm>
             <a:off x="7635240" y="1325880"/>
-            <a:ext cx="3474720" cy="1325880"/>
+            <a:ext cx="3474720" cy="1207008"/>
           </a:xfrm>
           <a:prstGeom prst="roundRect">
             <a:avLst>
-              <a:gd name="adj" fmla="val 8276"/>
+              <a:gd name="adj" fmla="val 9091"/>
             </a:avLst>
           </a:prstGeom>
           <a:solidFill>
@@ -12458,7 +12674,7 @@
         <p:spPr>
           <a:xfrm>
             <a:off x="7799832" y="1801368"/>
-            <a:ext cx="3145536" cy="758952"/>
+            <a:ext cx="3145536" cy="640080"/>
           </a:xfrm>
           <a:prstGeom prst="rect">
             <a:avLst/>
@@ -12498,12 +12714,12 @@
         </p:nvSpPr>
         <p:spPr>
           <a:xfrm>
-            <a:off x="7635240" y="2788920"/>
-            <a:ext cx="3474720" cy="1536192"/>
+            <a:off x="7635240" y="2670048"/>
+            <a:ext cx="3474720" cy="1377086"/>
           </a:xfrm>
           <a:prstGeom prst="roundRect">
             <a:avLst>
-              <a:gd name="adj" fmla="val 7143"/>
+              <a:gd name="adj" fmla="val 7968"/>
             </a:avLst>
           </a:prstGeom>
           <a:solidFill>
@@ -12525,7 +12741,7 @@
         </p:nvSpPr>
         <p:spPr>
           <a:xfrm>
-            <a:off x="7799832" y="2935224"/>
+            <a:off x="7799832" y="2816352"/>
             <a:ext cx="3145536" cy="256032"/>
           </a:xfrm>
           <a:prstGeom prst="rect">
@@ -12564,8 +12780,8 @@
         </p:nvSpPr>
         <p:spPr>
           <a:xfrm>
-            <a:off x="7818120" y="3300984"/>
-            <a:ext cx="3090672" cy="877824"/>
+            <a:off x="7818120" y="3182112"/>
+            <a:ext cx="3090672" cy="718718"/>
           </a:xfrm>
           <a:prstGeom prst="rect">
             <a:avLst/>
@@ -12639,12 +12855,12 @@
         </p:nvSpPr>
         <p:spPr>
           <a:xfrm>
-            <a:off x="7635240" y="4498848"/>
-            <a:ext cx="3474720" cy="1143000"/>
+            <a:off x="7635240" y="4184294"/>
+            <a:ext cx="3474720" cy="1466698"/>
           </a:xfrm>
           <a:prstGeom prst="roundRect">
             <a:avLst>
-              <a:gd name="adj" fmla="val 9600"/>
+              <a:gd name="adj" fmla="val 7481"/>
             </a:avLst>
           </a:prstGeom>
           <a:solidFill>
@@ -12666,7 +12882,7 @@
         </p:nvSpPr>
         <p:spPr>
           <a:xfrm>
-            <a:off x="7799832" y="4645152"/>
+            <a:off x="7799832" y="4330598"/>
             <a:ext cx="3145536" cy="256032"/>
           </a:xfrm>
           <a:prstGeom prst="rect">
@@ -12705,8 +12921,8 @@
         </p:nvSpPr>
         <p:spPr>
           <a:xfrm>
-            <a:off x="7799832" y="4974336"/>
-            <a:ext cx="3145536" cy="576072"/>
+            <a:off x="7799832" y="4659782"/>
+            <a:ext cx="3145536" cy="899770"/>
           </a:xfrm>
           <a:prstGeom prst="rect">
             <a:avLst/>
@@ -12732,7 +12948,7 @@
                 <a:ea typeface="Aptos" pitchFamily="34" charset="-122"/>
                 <a:cs typeface="Aptos" pitchFamily="34" charset="-120"/>
               </a:rPr>
-              <a:t>Use the concept to plan transparent communication, gather stakeholder input, protect trust, and make sure affected.</a:t>
+              <a:t>Use the concept to plan transparent communication, gather stakeholder input, protect trust, and make sure affected communities are considered early.</a:t>
             </a:r>
             <a:endParaRPr lang="en-US" sz="1320" dirty="0"/>
           </a:p>
@@ -13210,7 +13426,7 @@
                 <a:ea typeface="Aptos" pitchFamily="34" charset="-122"/>
                 <a:cs typeface="Aptos" pitchFamily="34" charset="-120"/>
               </a:rPr>
-              <a:t>Use the related plays to identify decisions, participants, timing, approvals, and documentation needed for responsible.</a:t>
+              <a:t>Use the related plays to identify decisions, participants, timing, approvals, and documentation needed for responsible implementation.</a:t>
             </a:r>
             <a:endParaRPr lang="en-US" sz="1320" dirty="0"/>
           </a:p>
@@ -13829,7 +14045,7 @@
                 <a:ea typeface="Aptos" pitchFamily="34" charset="-122"/>
                 <a:cs typeface="Aptos" pitchFamily="34" charset="-120"/>
               </a:rPr>
-              <a:t>Use linked tools when your department needs a structured worksheet, template, checklist, review process, or.</a:t>
+              <a:t>Use linked tools when your department needs a structured worksheet, template, checklist, review process, or documentation artifact.</a:t>
             </a:r>
             <a:endParaRPr lang="en-US" sz="1320" dirty="0"/>
           </a:p>
@@ -14339,11 +14555,11 @@
         <p:spPr>
           <a:xfrm>
             <a:off x="7635240" y="1325880"/>
-            <a:ext cx="3474720" cy="1325880"/>
+            <a:ext cx="3474720" cy="1207008"/>
           </a:xfrm>
           <a:prstGeom prst="roundRect">
             <a:avLst>
-              <a:gd name="adj" fmla="val 8276"/>
+              <a:gd name="adj" fmla="val 9091"/>
             </a:avLst>
           </a:prstGeom>
           <a:solidFill>
@@ -14405,7 +14621,7 @@
         <p:spPr>
           <a:xfrm>
             <a:off x="7799832" y="1801368"/>
-            <a:ext cx="3145536" cy="758952"/>
+            <a:ext cx="3145536" cy="640080"/>
           </a:xfrm>
           <a:prstGeom prst="rect">
             <a:avLst/>
@@ -14445,12 +14661,12 @@
         </p:nvSpPr>
         <p:spPr>
           <a:xfrm>
-            <a:off x="7635240" y="2788920"/>
-            <a:ext cx="3474720" cy="1536192"/>
+            <a:off x="7635240" y="2670048"/>
+            <a:ext cx="3474720" cy="1377086"/>
           </a:xfrm>
           <a:prstGeom prst="roundRect">
             <a:avLst>
-              <a:gd name="adj" fmla="val 7143"/>
+              <a:gd name="adj" fmla="val 7968"/>
             </a:avLst>
           </a:prstGeom>
           <a:solidFill>
@@ -14472,7 +14688,7 @@
         </p:nvSpPr>
         <p:spPr>
           <a:xfrm>
-            <a:off x="7799832" y="2935224"/>
+            <a:off x="7799832" y="2816352"/>
             <a:ext cx="3145536" cy="256032"/>
           </a:xfrm>
           <a:prstGeom prst="rect">
@@ -14511,8 +14727,8 @@
         </p:nvSpPr>
         <p:spPr>
           <a:xfrm>
-            <a:off x="7818120" y="3300984"/>
-            <a:ext cx="3090672" cy="877824"/>
+            <a:off x="7818120" y="3182112"/>
+            <a:ext cx="3090672" cy="718718"/>
           </a:xfrm>
           <a:prstGeom prst="rect">
             <a:avLst/>
@@ -14569,12 +14785,12 @@
         </p:nvSpPr>
         <p:spPr>
           <a:xfrm>
-            <a:off x="7635240" y="4498848"/>
-            <a:ext cx="3474720" cy="1143000"/>
+            <a:off x="7635240" y="4184294"/>
+            <a:ext cx="3474720" cy="1466698"/>
           </a:xfrm>
           <a:prstGeom prst="roundRect">
             <a:avLst>
-              <a:gd name="adj" fmla="val 9600"/>
+              <a:gd name="adj" fmla="val 7481"/>
             </a:avLst>
           </a:prstGeom>
           <a:solidFill>
@@ -14596,7 +14812,7 @@
         </p:nvSpPr>
         <p:spPr>
           <a:xfrm>
-            <a:off x="7799832" y="4645152"/>
+            <a:off x="7799832" y="4330598"/>
             <a:ext cx="3145536" cy="256032"/>
           </a:xfrm>
           <a:prstGeom prst="rect">
@@ -14635,8 +14851,8 @@
         </p:nvSpPr>
         <p:spPr>
           <a:xfrm>
-            <a:off x="7799832" y="4974336"/>
-            <a:ext cx="3145536" cy="576072"/>
+            <a:off x="7799832" y="4659782"/>
+            <a:ext cx="3145536" cy="899770"/>
           </a:xfrm>
           <a:prstGeom prst="rect">
             <a:avLst/>
@@ -14662,7 +14878,7 @@
                 <a:ea typeface="Aptos" pitchFamily="34" charset="-122"/>
                 <a:cs typeface="Aptos" pitchFamily="34" charset="-120"/>
               </a:rPr>
-              <a:t>Use the assignment to test whether you can explain the concept, apply it to a realistic public health situation, and.</a:t>
+              <a:t>Use the assignment to test whether you can explain the concept, apply it to a realistic public health situation, and identify what would need review before the work moves forward.</a:t>
             </a:r>
             <a:endParaRPr lang="en-US" sz="1320" dirty="0"/>
           </a:p>
@@ -15031,11 +15247,11 @@
         <p:spPr>
           <a:xfrm>
             <a:off x="7635240" y="1325880"/>
-            <a:ext cx="3474720" cy="1325880"/>
+            <a:ext cx="3474720" cy="1207008"/>
           </a:xfrm>
           <a:prstGeom prst="roundRect">
             <a:avLst>
-              <a:gd name="adj" fmla="val 8276"/>
+              <a:gd name="adj" fmla="val 9091"/>
             </a:avLst>
           </a:prstGeom>
           <a:solidFill>
@@ -15097,7 +15313,7 @@
         <p:spPr>
           <a:xfrm>
             <a:off x="7799832" y="1801368"/>
-            <a:ext cx="3145536" cy="758952"/>
+            <a:ext cx="3145536" cy="640080"/>
           </a:xfrm>
           <a:prstGeom prst="rect">
             <a:avLst/>
@@ -15137,12 +15353,12 @@
         </p:nvSpPr>
         <p:spPr>
           <a:xfrm>
-            <a:off x="7635240" y="2788920"/>
-            <a:ext cx="3474720" cy="1536192"/>
+            <a:off x="7635240" y="2670048"/>
+            <a:ext cx="3474720" cy="1377086"/>
           </a:xfrm>
           <a:prstGeom prst="roundRect">
             <a:avLst>
-              <a:gd name="adj" fmla="val 7143"/>
+              <a:gd name="adj" fmla="val 7968"/>
             </a:avLst>
           </a:prstGeom>
           <a:solidFill>
@@ -15164,8 +15380,8 @@
         </p:nvSpPr>
         <p:spPr>
           <a:xfrm>
-            <a:off x="7799832" y="2935224"/>
-            <a:ext cx="3145536" cy="256032"/>
+            <a:off x="7799832" y="2798064"/>
+            <a:ext cx="3145536" cy="237744"/>
           </a:xfrm>
           <a:prstGeom prst="rect">
             <a:avLst/>
@@ -15181,7 +15397,7 @@
               <a:buNone/>
             </a:pPr>
             <a:r>
-              <a:rPr lang="en-US" sz="1300" b="1" dirty="0">
+              <a:rPr lang="en-US" sz="1250" b="1" dirty="0">
                 <a:solidFill>
                   <a:srgbClr val="0068B7"/>
                 </a:solidFill>
@@ -15189,101 +15405,317 @@
                 <a:ea typeface="Aptos" pitchFamily="34" charset="-122"/>
                 <a:cs typeface="Aptos" pitchFamily="34" charset="-120"/>
               </a:rPr>
-              <a:t>Concept checkpoints</a:t>
-            </a:r>
-            <a:endParaRPr lang="en-US" sz="1300" dirty="0"/>
-          </a:p>
-        </p:txBody>
-      </p:sp>
-      <p:sp>
-        <p:nvSpPr>
-          <p:cNvPr id="15" name="Text 13"/>
-          <p:cNvSpPr/>
-          <p:nvPr/>
-        </p:nvSpPr>
-        <p:spPr>
-          <a:xfrm>
-            <a:off x="7818120" y="3300984"/>
-            <a:ext cx="3090672" cy="877824"/>
-          </a:xfrm>
-          <a:prstGeom prst="rect">
-            <a:avLst/>
-          </a:prstGeom>
-          <a:noFill/>
-          <a:ln/>
-        </p:spPr>
-        <p:txBody>
-          <a:bodyPr wrap="square" lIns="508" tIns="508" rIns="508" bIns="508" rtlCol="0" anchor="t">
+              <a:t>Trust cycle</a:t>
+            </a:r>
+            <a:endParaRPr lang="en-US" sz="1250" dirty="0"/>
+          </a:p>
+        </p:txBody>
+      </p:sp>
+      <p:sp>
+        <p:nvSpPr>
+          <p:cNvPr id="15" name="Shape 13"/>
+          <p:cNvSpPr/>
+          <p:nvPr/>
+        </p:nvSpPr>
+        <p:spPr>
+          <a:xfrm>
+            <a:off x="8763000" y="3351276"/>
+            <a:ext cx="164592" cy="0"/>
+          </a:xfrm>
+          <a:prstGeom prst="line">
+            <a:avLst/>
+          </a:prstGeom>
+          <a:noFill/>
+          <a:ln w="15240">
+            <a:solidFill>
+              <a:srgbClr val="8ABBD8"/>
+            </a:solidFill>
+            <a:prstDash val="solid"/>
+          </a:ln>
+        </p:spPr>
+      </p:sp>
+      <p:sp>
+        <p:nvSpPr>
+          <p:cNvPr id="16" name="Shape 14"/>
+          <p:cNvSpPr/>
+          <p:nvPr/>
+        </p:nvSpPr>
+        <p:spPr>
+          <a:xfrm>
+            <a:off x="7872984" y="3200400"/>
+            <a:ext cx="890016" cy="301752"/>
+          </a:xfrm>
+          <a:prstGeom prst="roundRect">
+            <a:avLst>
+              <a:gd name="adj" fmla="val 24242"/>
+            </a:avLst>
+          </a:prstGeom>
+          <a:solidFill>
+            <a:srgbClr val="0068B7"/>
+          </a:solidFill>
+          <a:ln w="12700">
+            <a:solidFill>
+              <a:srgbClr val="0068B7"/>
+            </a:solidFill>
+            <a:prstDash val="solid"/>
+          </a:ln>
+        </p:spPr>
+      </p:sp>
+      <p:sp>
+        <p:nvSpPr>
+          <p:cNvPr id="17" name="Text 15"/>
+          <p:cNvSpPr/>
+          <p:nvPr/>
+        </p:nvSpPr>
+        <p:spPr>
+          <a:xfrm>
+            <a:off x="7909560" y="3273552"/>
+            <a:ext cx="816864" cy="146304"/>
+          </a:xfrm>
+          <a:prstGeom prst="rect">
+            <a:avLst/>
+          </a:prstGeom>
+          <a:noFill/>
+          <a:ln/>
+        </p:spPr>
+        <p:txBody>
+          <a:bodyPr wrap="square" lIns="0" tIns="0" rIns="0" bIns="0" rtlCol="0" anchor="ctr">
             <a:normAutofit/>
           </a:bodyPr>
           <a:lstStyle/>
           <a:p>
-            <a:pPr indent="0" marL="0">
-              <a:buNone/>
-            </a:pPr>
-            <a:r>
-              <a:rPr lang="en-US" sz="1220" dirty="0">
-                <a:solidFill>
-                  <a:srgbClr val="17364A"/>
-                </a:solidFill>
-                <a:latin typeface="Aptos" pitchFamily="34" charset="0"/>
-                <a:ea typeface="Aptos" pitchFamily="34" charset="-122"/>
-                <a:cs typeface="Aptos" pitchFamily="34" charset="-120"/>
-              </a:rPr>
-              <a:t>Natural language processing is a branch of AI that works with.</a:t>
-            </a:r>
-            <a:endParaRPr lang="en-US" sz="1220" dirty="0"/>
-          </a:p>
-          <a:p>
-            <a:pPr indent="0" marL="0">
-              <a:buNone/>
-            </a:pPr>
-            <a:r>
-              <a:rPr lang="en-US" sz="1220" dirty="0">
-                <a:solidFill>
-                  <a:srgbClr val="17364A"/>
-                </a:solidFill>
-                <a:latin typeface="Aptos" pitchFamily="34" charset="0"/>
-                <a:ea typeface="Aptos" pitchFamily="34" charset="-122"/>
-                <a:cs typeface="Aptos" pitchFamily="34" charset="-120"/>
-              </a:rPr>
-              <a:t>Public health agencies often hold important information in.</a:t>
-            </a:r>
-            <a:endParaRPr lang="en-US" sz="1220" dirty="0"/>
-          </a:p>
-          <a:p>
-            <a:pPr indent="0" marL="0">
-              <a:buNone/>
-            </a:pPr>
-            <a:r>
-              <a:rPr lang="en-US" sz="1220" dirty="0">
-                <a:solidFill>
-                  <a:srgbClr val="17364A"/>
-                </a:solidFill>
-                <a:latin typeface="Aptos" pitchFamily="34" charset="0"/>
-                <a:ea typeface="Aptos" pitchFamily="34" charset="-122"/>
-                <a:cs typeface="Aptos" pitchFamily="34" charset="-120"/>
-              </a:rPr>
-              <a:t>This module teaches learners how NLP can support public health.</a:t>
-            </a:r>
-            <a:endParaRPr lang="en-US" sz="1220" dirty="0"/>
-          </a:p>
-        </p:txBody>
-      </p:sp>
-      <p:sp>
-        <p:nvSpPr>
-          <p:cNvPr id="16" name="Shape 14"/>
-          <p:cNvSpPr/>
-          <p:nvPr/>
-        </p:nvSpPr>
-        <p:spPr>
-          <a:xfrm>
-            <a:off x="7635240" y="4498848"/>
-            <a:ext cx="3474720" cy="1143000"/>
+            <a:pPr algn="ctr" indent="0" marL="0">
+              <a:buNone/>
+            </a:pPr>
+            <a:r>
+              <a:rPr lang="en-US" sz="880" b="1" dirty="0">
+                <a:solidFill>
+                  <a:srgbClr val="FFFFFF"/>
+                </a:solidFill>
+                <a:latin typeface="Aptos" pitchFamily="34" charset="0"/>
+                <a:ea typeface="Aptos" pitchFamily="34" charset="-122"/>
+                <a:cs typeface="Aptos" pitchFamily="34" charset="-120"/>
+              </a:rPr>
+              <a:t>Listen</a:t>
+            </a:r>
+            <a:endParaRPr lang="en-US" sz="880" dirty="0"/>
+          </a:p>
+        </p:txBody>
+      </p:sp>
+      <p:sp>
+        <p:nvSpPr>
+          <p:cNvPr id="18" name="Shape 16"/>
+          <p:cNvSpPr/>
+          <p:nvPr/>
+        </p:nvSpPr>
+        <p:spPr>
+          <a:xfrm>
+            <a:off x="9817608" y="3351276"/>
+            <a:ext cx="164592" cy="0"/>
+          </a:xfrm>
+          <a:prstGeom prst="line">
+            <a:avLst/>
+          </a:prstGeom>
+          <a:noFill/>
+          <a:ln w="15240">
+            <a:solidFill>
+              <a:srgbClr val="8ABBD8"/>
+            </a:solidFill>
+            <a:prstDash val="solid"/>
+          </a:ln>
+        </p:spPr>
+      </p:sp>
+      <p:sp>
+        <p:nvSpPr>
+          <p:cNvPr id="19" name="Shape 17"/>
+          <p:cNvSpPr/>
+          <p:nvPr/>
+        </p:nvSpPr>
+        <p:spPr>
+          <a:xfrm>
+            <a:off x="8927592" y="3200400"/>
+            <a:ext cx="890016" cy="301752"/>
           </a:xfrm>
           <a:prstGeom prst="roundRect">
             <a:avLst>
-              <a:gd name="adj" fmla="val 9600"/>
+              <a:gd name="adj" fmla="val 24242"/>
+            </a:avLst>
+          </a:prstGeom>
+          <a:solidFill>
+            <a:srgbClr val="2F8A28"/>
+          </a:solidFill>
+          <a:ln w="12700">
+            <a:solidFill>
+              <a:srgbClr val="2F8A28"/>
+            </a:solidFill>
+            <a:prstDash val="solid"/>
+          </a:ln>
+        </p:spPr>
+      </p:sp>
+      <p:sp>
+        <p:nvSpPr>
+          <p:cNvPr id="20" name="Text 18"/>
+          <p:cNvSpPr/>
+          <p:nvPr/>
+        </p:nvSpPr>
+        <p:spPr>
+          <a:xfrm>
+            <a:off x="8964168" y="3273552"/>
+            <a:ext cx="816864" cy="146304"/>
+          </a:xfrm>
+          <a:prstGeom prst="rect">
+            <a:avLst/>
+          </a:prstGeom>
+          <a:noFill/>
+          <a:ln/>
+        </p:spPr>
+        <p:txBody>
+          <a:bodyPr wrap="square" lIns="0" tIns="0" rIns="0" bIns="0" rtlCol="0" anchor="ctr">
+            <a:normAutofit/>
+          </a:bodyPr>
+          <a:lstStyle/>
+          <a:p>
+            <a:pPr algn="ctr" indent="0" marL="0">
+              <a:buNone/>
+            </a:pPr>
+            <a:r>
+              <a:rPr lang="en-US" sz="880" b="1" dirty="0">
+                <a:solidFill>
+                  <a:srgbClr val="FFFFFF"/>
+                </a:solidFill>
+                <a:latin typeface="Aptos" pitchFamily="34" charset="0"/>
+                <a:ea typeface="Aptos" pitchFamily="34" charset="-122"/>
+                <a:cs typeface="Aptos" pitchFamily="34" charset="-120"/>
+              </a:rPr>
+              <a:t>Adapt</a:t>
+            </a:r>
+            <a:endParaRPr lang="en-US" sz="880" dirty="0"/>
+          </a:p>
+        </p:txBody>
+      </p:sp>
+      <p:sp>
+        <p:nvSpPr>
+          <p:cNvPr id="21" name="Shape 19"/>
+          <p:cNvSpPr/>
+          <p:nvPr/>
+        </p:nvSpPr>
+        <p:spPr>
+          <a:xfrm>
+            <a:off x="9982200" y="3200400"/>
+            <a:ext cx="890016" cy="301752"/>
+          </a:xfrm>
+          <a:prstGeom prst="roundRect">
+            <a:avLst>
+              <a:gd name="adj" fmla="val 24242"/>
+            </a:avLst>
+          </a:prstGeom>
+          <a:solidFill>
+            <a:srgbClr val="6A4CA3"/>
+          </a:solidFill>
+          <a:ln w="12700">
+            <a:solidFill>
+              <a:srgbClr val="6A4CA3"/>
+            </a:solidFill>
+            <a:prstDash val="solid"/>
+          </a:ln>
+        </p:spPr>
+      </p:sp>
+      <p:sp>
+        <p:nvSpPr>
+          <p:cNvPr id="22" name="Text 20"/>
+          <p:cNvSpPr/>
+          <p:nvPr/>
+        </p:nvSpPr>
+        <p:spPr>
+          <a:xfrm>
+            <a:off x="10018776" y="3273552"/>
+            <a:ext cx="816864" cy="146304"/>
+          </a:xfrm>
+          <a:prstGeom prst="rect">
+            <a:avLst/>
+          </a:prstGeom>
+          <a:noFill/>
+          <a:ln/>
+        </p:spPr>
+        <p:txBody>
+          <a:bodyPr wrap="square" lIns="0" tIns="0" rIns="0" bIns="0" rtlCol="0" anchor="ctr">
+            <a:normAutofit/>
+          </a:bodyPr>
+          <a:lstStyle/>
+          <a:p>
+            <a:pPr algn="ctr" indent="0" marL="0">
+              <a:buNone/>
+            </a:pPr>
+            <a:r>
+              <a:rPr lang="en-US" sz="880" b="1" dirty="0">
+                <a:solidFill>
+                  <a:srgbClr val="FFFFFF"/>
+                </a:solidFill>
+                <a:latin typeface="Aptos" pitchFamily="34" charset="0"/>
+                <a:ea typeface="Aptos" pitchFamily="34" charset="-122"/>
+                <a:cs typeface="Aptos" pitchFamily="34" charset="-120"/>
+              </a:rPr>
+              <a:t>Report</a:t>
+            </a:r>
+            <a:endParaRPr lang="en-US" sz="880" dirty="0"/>
+          </a:p>
+        </p:txBody>
+      </p:sp>
+      <p:sp>
+        <p:nvSpPr>
+          <p:cNvPr id="23" name="Text 21"/>
+          <p:cNvSpPr/>
+          <p:nvPr/>
+        </p:nvSpPr>
+        <p:spPr>
+          <a:xfrm>
+            <a:off x="7854696" y="3694176"/>
+            <a:ext cx="3035808" cy="206654"/>
+          </a:xfrm>
+          <a:prstGeom prst="rect">
+            <a:avLst/>
+          </a:prstGeom>
+          <a:noFill/>
+          <a:ln/>
+        </p:spPr>
+        <p:txBody>
+          <a:bodyPr wrap="square" lIns="254" tIns="254" rIns="254" bIns="254" rtlCol="0" anchor="t">
+            <a:normAutofit/>
+          </a:bodyPr>
+          <a:lstStyle/>
+          <a:p>
+            <a:pPr indent="0" marL="0">
+              <a:buNone/>
+            </a:pPr>
+            <a:r>
+              <a:rPr lang="en-US" sz="1120" dirty="0">
+                <a:solidFill>
+                  <a:srgbClr val="17364A"/>
+                </a:solidFill>
+                <a:latin typeface="Aptos" pitchFamily="34" charset="0"/>
+                <a:ea typeface="Aptos" pitchFamily="34" charset="-122"/>
+                <a:cs typeface="Aptos" pitchFamily="34" charset="-120"/>
+              </a:rPr>
+              <a:t>Communication and engagement are stronger when feedback changes the work and the department reports what.</a:t>
+            </a:r>
+            <a:endParaRPr lang="en-US" sz="1120" dirty="0"/>
+          </a:p>
+        </p:txBody>
+      </p:sp>
+      <p:sp>
+        <p:nvSpPr>
+          <p:cNvPr id="24" name="Shape 22"/>
+          <p:cNvSpPr/>
+          <p:nvPr/>
+        </p:nvSpPr>
+        <p:spPr>
+          <a:xfrm>
+            <a:off x="7635240" y="4184294"/>
+            <a:ext cx="3474720" cy="1466698"/>
+          </a:xfrm>
+          <a:prstGeom prst="roundRect">
+            <a:avLst>
+              <a:gd name="adj" fmla="val 7481"/>
             </a:avLst>
           </a:prstGeom>
           <a:solidFill>
@@ -15299,13 +15731,13 @@
       </p:sp>
       <p:sp>
         <p:nvSpPr>
-          <p:cNvPr id="17" name="Text 15"/>
-          <p:cNvSpPr/>
-          <p:nvPr/>
-        </p:nvSpPr>
-        <p:spPr>
-          <a:xfrm>
-            <a:off x="7799832" y="4645152"/>
+          <p:cNvPr id="25" name="Text 23"/>
+          <p:cNvSpPr/>
+          <p:nvPr/>
+        </p:nvSpPr>
+        <p:spPr>
+          <a:xfrm>
+            <a:off x="7799832" y="4330598"/>
             <a:ext cx="3145536" cy="256032"/>
           </a:xfrm>
           <a:prstGeom prst="rect">
@@ -15338,14 +15770,14 @@
       </p:sp>
       <p:sp>
         <p:nvSpPr>
-          <p:cNvPr id="18" name="Text 16"/>
-          <p:cNvSpPr/>
-          <p:nvPr/>
-        </p:nvSpPr>
-        <p:spPr>
-          <a:xfrm>
-            <a:off x="7799832" y="4974336"/>
-            <a:ext cx="3145536" cy="576072"/>
+          <p:cNvPr id="26" name="Text 24"/>
+          <p:cNvSpPr/>
+          <p:nvPr/>
+        </p:nvSpPr>
+        <p:spPr>
+          <a:xfrm>
+            <a:off x="7799832" y="4659782"/>
+            <a:ext cx="3145536" cy="899770"/>
           </a:xfrm>
           <a:prstGeom prst="rect">
             <a:avLst/>
@@ -15371,7 +15803,7 @@
                 <a:ea typeface="Aptos" pitchFamily="34" charset="-122"/>
                 <a:cs typeface="Aptos" pitchFamily="34" charset="-120"/>
               </a:rPr>
-              <a:t>Use the concept to plan transparent communication, gather stakeholder input, protect trust, and make sure affected.</a:t>
+              <a:t>Use the concept to plan transparent communication, gather stakeholder input, protect trust, and make sure affected communities are considered early.</a:t>
             </a:r>
             <a:endParaRPr lang="en-US" sz="1320" dirty="0"/>
           </a:p>
@@ -15740,11 +16172,11 @@
         <p:spPr>
           <a:xfrm>
             <a:off x="7635240" y="1325880"/>
-            <a:ext cx="3474720" cy="1325880"/>
+            <a:ext cx="3474720" cy="1255471"/>
           </a:xfrm>
           <a:prstGeom prst="roundRect">
             <a:avLst>
-              <a:gd name="adj" fmla="val 8276"/>
+              <a:gd name="adj" fmla="val 8740"/>
             </a:avLst>
           </a:prstGeom>
           <a:solidFill>
@@ -15806,7 +16238,7 @@
         <p:spPr>
           <a:xfrm>
             <a:off x="7799832" y="1801368"/>
-            <a:ext cx="3145536" cy="758952"/>
+            <a:ext cx="3145536" cy="688543"/>
           </a:xfrm>
           <a:prstGeom prst="rect">
             <a:avLst/>
@@ -15846,12 +16278,12 @@
         </p:nvSpPr>
         <p:spPr>
           <a:xfrm>
-            <a:off x="7635240" y="2788920"/>
-            <a:ext cx="3474720" cy="1536192"/>
+            <a:off x="7635240" y="2718511"/>
+            <a:ext cx="3474720" cy="1328623"/>
           </a:xfrm>
           <a:prstGeom prst="roundRect">
             <a:avLst>
-              <a:gd name="adj" fmla="val 7143"/>
+              <a:gd name="adj" fmla="val 8259"/>
             </a:avLst>
           </a:prstGeom>
           <a:solidFill>
@@ -15873,8 +16305,8 @@
         </p:nvSpPr>
         <p:spPr>
           <a:xfrm>
-            <a:off x="7799832" y="2935224"/>
-            <a:ext cx="3145536" cy="256032"/>
+            <a:off x="7799832" y="2846527"/>
+            <a:ext cx="3145536" cy="237744"/>
           </a:xfrm>
           <a:prstGeom prst="rect">
             <a:avLst/>
@@ -15890,7 +16322,7 @@
               <a:buNone/>
             </a:pPr>
             <a:r>
-              <a:rPr lang="en-US" sz="1300" b="1" dirty="0">
+              <a:rPr lang="en-US" sz="1250" b="1" dirty="0">
                 <a:solidFill>
                   <a:srgbClr val="0068B7"/>
                 </a:solidFill>
@@ -15898,101 +16330,317 @@
                 <a:ea typeface="Aptos" pitchFamily="34" charset="-122"/>
                 <a:cs typeface="Aptos" pitchFamily="34" charset="-120"/>
               </a:rPr>
-              <a:t>Concept checkpoints</a:t>
-            </a:r>
-            <a:endParaRPr lang="en-US" sz="1300" dirty="0"/>
-          </a:p>
-        </p:txBody>
-      </p:sp>
-      <p:sp>
-        <p:nvSpPr>
-          <p:cNvPr id="15" name="Text 13"/>
-          <p:cNvSpPr/>
-          <p:nvPr/>
-        </p:nvSpPr>
-        <p:spPr>
-          <a:xfrm>
-            <a:off x="7818120" y="3300984"/>
-            <a:ext cx="3090672" cy="877824"/>
-          </a:xfrm>
-          <a:prstGeom prst="rect">
-            <a:avLst/>
-          </a:prstGeom>
-          <a:noFill/>
-          <a:ln/>
-        </p:spPr>
-        <p:txBody>
-          <a:bodyPr wrap="square" lIns="508" tIns="508" rIns="508" bIns="508" rtlCol="0" anchor="t">
+              <a:t>Trust cycle</a:t>
+            </a:r>
+            <a:endParaRPr lang="en-US" sz="1250" dirty="0"/>
+          </a:p>
+        </p:txBody>
+      </p:sp>
+      <p:sp>
+        <p:nvSpPr>
+          <p:cNvPr id="15" name="Shape 13"/>
+          <p:cNvSpPr/>
+          <p:nvPr/>
+        </p:nvSpPr>
+        <p:spPr>
+          <a:xfrm>
+            <a:off x="8763000" y="3399739"/>
+            <a:ext cx="164592" cy="0"/>
+          </a:xfrm>
+          <a:prstGeom prst="line">
+            <a:avLst/>
+          </a:prstGeom>
+          <a:noFill/>
+          <a:ln w="15240">
+            <a:solidFill>
+              <a:srgbClr val="8ABBD8"/>
+            </a:solidFill>
+            <a:prstDash val="solid"/>
+          </a:ln>
+        </p:spPr>
+      </p:sp>
+      <p:sp>
+        <p:nvSpPr>
+          <p:cNvPr id="16" name="Shape 14"/>
+          <p:cNvSpPr/>
+          <p:nvPr/>
+        </p:nvSpPr>
+        <p:spPr>
+          <a:xfrm>
+            <a:off x="7872984" y="3248863"/>
+            <a:ext cx="890016" cy="301752"/>
+          </a:xfrm>
+          <a:prstGeom prst="roundRect">
+            <a:avLst>
+              <a:gd name="adj" fmla="val 24242"/>
+            </a:avLst>
+          </a:prstGeom>
+          <a:solidFill>
+            <a:srgbClr val="0068B7"/>
+          </a:solidFill>
+          <a:ln w="12700">
+            <a:solidFill>
+              <a:srgbClr val="0068B7"/>
+            </a:solidFill>
+            <a:prstDash val="solid"/>
+          </a:ln>
+        </p:spPr>
+      </p:sp>
+      <p:sp>
+        <p:nvSpPr>
+          <p:cNvPr id="17" name="Text 15"/>
+          <p:cNvSpPr/>
+          <p:nvPr/>
+        </p:nvSpPr>
+        <p:spPr>
+          <a:xfrm>
+            <a:off x="7909560" y="3322015"/>
+            <a:ext cx="816864" cy="146304"/>
+          </a:xfrm>
+          <a:prstGeom prst="rect">
+            <a:avLst/>
+          </a:prstGeom>
+          <a:noFill/>
+          <a:ln/>
+        </p:spPr>
+        <p:txBody>
+          <a:bodyPr wrap="square" lIns="0" tIns="0" rIns="0" bIns="0" rtlCol="0" anchor="ctr">
             <a:normAutofit/>
           </a:bodyPr>
           <a:lstStyle/>
           <a:p>
-            <a:pPr indent="0" marL="0">
-              <a:buNone/>
-            </a:pPr>
-            <a:r>
-              <a:rPr lang="en-US" sz="1220" dirty="0">
-                <a:solidFill>
-                  <a:srgbClr val="17364A"/>
-                </a:solidFill>
-                <a:latin typeface="Aptos" pitchFamily="34" charset="0"/>
-                <a:ea typeface="Aptos" pitchFamily="34" charset="-122"/>
-                <a:cs typeface="Aptos" pitchFamily="34" charset="-120"/>
-              </a:rPr>
-              <a:t>NLP can reduce burden by helping staff find, organize, classify,.</a:t>
-            </a:r>
-            <a:endParaRPr lang="en-US" sz="1220" dirty="0"/>
-          </a:p>
-          <a:p>
-            <a:pPr indent="0" marL="0">
-              <a:buNone/>
-            </a:pPr>
-            <a:r>
-              <a:rPr lang="en-US" sz="1220" dirty="0">
-                <a:solidFill>
-                  <a:srgbClr val="17364A"/>
-                </a:solidFill>
-                <a:latin typeface="Aptos" pitchFamily="34" charset="0"/>
-                <a:ea typeface="Aptos" pitchFamily="34" charset="-122"/>
-                <a:cs typeface="Aptos" pitchFamily="34" charset="-120"/>
-              </a:rPr>
-              <a:t>It can support case investigation, environmental health complaint.</a:t>
-            </a:r>
-            <a:endParaRPr lang="en-US" sz="1220" dirty="0"/>
-          </a:p>
-          <a:p>
-            <a:pPr indent="0" marL="0">
-              <a:buNone/>
-            </a:pPr>
-            <a:r>
-              <a:rPr lang="en-US" sz="1220" dirty="0">
-                <a:solidFill>
-                  <a:srgbClr val="17364A"/>
-                </a:solidFill>
-                <a:latin typeface="Aptos" pitchFamily="34" charset="0"/>
-                <a:ea typeface="Aptos" pitchFamily="34" charset="-122"/>
-                <a:cs typeface="Aptos" pitchFamily="34" charset="-120"/>
-              </a:rPr>
-              <a:t>NLP outputs should not be treated as facts without review.</a:t>
-            </a:r>
-            <a:endParaRPr lang="en-US" sz="1220" dirty="0"/>
-          </a:p>
-        </p:txBody>
-      </p:sp>
-      <p:sp>
-        <p:nvSpPr>
-          <p:cNvPr id="16" name="Shape 14"/>
-          <p:cNvSpPr/>
-          <p:nvPr/>
-        </p:nvSpPr>
-        <p:spPr>
-          <a:xfrm>
-            <a:off x="7635240" y="4498848"/>
-            <a:ext cx="3474720" cy="1143000"/>
+            <a:pPr algn="ctr" indent="0" marL="0">
+              <a:buNone/>
+            </a:pPr>
+            <a:r>
+              <a:rPr lang="en-US" sz="880" b="1" dirty="0">
+                <a:solidFill>
+                  <a:srgbClr val="FFFFFF"/>
+                </a:solidFill>
+                <a:latin typeface="Aptos" pitchFamily="34" charset="0"/>
+                <a:ea typeface="Aptos" pitchFamily="34" charset="-122"/>
+                <a:cs typeface="Aptos" pitchFamily="34" charset="-120"/>
+              </a:rPr>
+              <a:t>Listen</a:t>
+            </a:r>
+            <a:endParaRPr lang="en-US" sz="880" dirty="0"/>
+          </a:p>
+        </p:txBody>
+      </p:sp>
+      <p:sp>
+        <p:nvSpPr>
+          <p:cNvPr id="18" name="Shape 16"/>
+          <p:cNvSpPr/>
+          <p:nvPr/>
+        </p:nvSpPr>
+        <p:spPr>
+          <a:xfrm>
+            <a:off x="9817608" y="3399739"/>
+            <a:ext cx="164592" cy="0"/>
+          </a:xfrm>
+          <a:prstGeom prst="line">
+            <a:avLst/>
+          </a:prstGeom>
+          <a:noFill/>
+          <a:ln w="15240">
+            <a:solidFill>
+              <a:srgbClr val="8ABBD8"/>
+            </a:solidFill>
+            <a:prstDash val="solid"/>
+          </a:ln>
+        </p:spPr>
+      </p:sp>
+      <p:sp>
+        <p:nvSpPr>
+          <p:cNvPr id="19" name="Shape 17"/>
+          <p:cNvSpPr/>
+          <p:nvPr/>
+        </p:nvSpPr>
+        <p:spPr>
+          <a:xfrm>
+            <a:off x="8927592" y="3248863"/>
+            <a:ext cx="890016" cy="301752"/>
           </a:xfrm>
           <a:prstGeom prst="roundRect">
             <a:avLst>
-              <a:gd name="adj" fmla="val 9600"/>
+              <a:gd name="adj" fmla="val 24242"/>
+            </a:avLst>
+          </a:prstGeom>
+          <a:solidFill>
+            <a:srgbClr val="2F8A28"/>
+          </a:solidFill>
+          <a:ln w="12700">
+            <a:solidFill>
+              <a:srgbClr val="2F8A28"/>
+            </a:solidFill>
+            <a:prstDash val="solid"/>
+          </a:ln>
+        </p:spPr>
+      </p:sp>
+      <p:sp>
+        <p:nvSpPr>
+          <p:cNvPr id="20" name="Text 18"/>
+          <p:cNvSpPr/>
+          <p:nvPr/>
+        </p:nvSpPr>
+        <p:spPr>
+          <a:xfrm>
+            <a:off x="8964168" y="3322015"/>
+            <a:ext cx="816864" cy="146304"/>
+          </a:xfrm>
+          <a:prstGeom prst="rect">
+            <a:avLst/>
+          </a:prstGeom>
+          <a:noFill/>
+          <a:ln/>
+        </p:spPr>
+        <p:txBody>
+          <a:bodyPr wrap="square" lIns="0" tIns="0" rIns="0" bIns="0" rtlCol="0" anchor="ctr">
+            <a:normAutofit/>
+          </a:bodyPr>
+          <a:lstStyle/>
+          <a:p>
+            <a:pPr algn="ctr" indent="0" marL="0">
+              <a:buNone/>
+            </a:pPr>
+            <a:r>
+              <a:rPr lang="en-US" sz="880" b="1" dirty="0">
+                <a:solidFill>
+                  <a:srgbClr val="FFFFFF"/>
+                </a:solidFill>
+                <a:latin typeface="Aptos" pitchFamily="34" charset="0"/>
+                <a:ea typeface="Aptos" pitchFamily="34" charset="-122"/>
+                <a:cs typeface="Aptos" pitchFamily="34" charset="-120"/>
+              </a:rPr>
+              <a:t>Adapt</a:t>
+            </a:r>
+            <a:endParaRPr lang="en-US" sz="880" dirty="0"/>
+          </a:p>
+        </p:txBody>
+      </p:sp>
+      <p:sp>
+        <p:nvSpPr>
+          <p:cNvPr id="21" name="Shape 19"/>
+          <p:cNvSpPr/>
+          <p:nvPr/>
+        </p:nvSpPr>
+        <p:spPr>
+          <a:xfrm>
+            <a:off x="9982200" y="3248863"/>
+            <a:ext cx="890016" cy="301752"/>
+          </a:xfrm>
+          <a:prstGeom prst="roundRect">
+            <a:avLst>
+              <a:gd name="adj" fmla="val 24242"/>
+            </a:avLst>
+          </a:prstGeom>
+          <a:solidFill>
+            <a:srgbClr val="6A4CA3"/>
+          </a:solidFill>
+          <a:ln w="12700">
+            <a:solidFill>
+              <a:srgbClr val="6A4CA3"/>
+            </a:solidFill>
+            <a:prstDash val="solid"/>
+          </a:ln>
+        </p:spPr>
+      </p:sp>
+      <p:sp>
+        <p:nvSpPr>
+          <p:cNvPr id="22" name="Text 20"/>
+          <p:cNvSpPr/>
+          <p:nvPr/>
+        </p:nvSpPr>
+        <p:spPr>
+          <a:xfrm>
+            <a:off x="10018776" y="3322015"/>
+            <a:ext cx="816864" cy="146304"/>
+          </a:xfrm>
+          <a:prstGeom prst="rect">
+            <a:avLst/>
+          </a:prstGeom>
+          <a:noFill/>
+          <a:ln/>
+        </p:spPr>
+        <p:txBody>
+          <a:bodyPr wrap="square" lIns="0" tIns="0" rIns="0" bIns="0" rtlCol="0" anchor="ctr">
+            <a:normAutofit/>
+          </a:bodyPr>
+          <a:lstStyle/>
+          <a:p>
+            <a:pPr algn="ctr" indent="0" marL="0">
+              <a:buNone/>
+            </a:pPr>
+            <a:r>
+              <a:rPr lang="en-US" sz="880" b="1" dirty="0">
+                <a:solidFill>
+                  <a:srgbClr val="FFFFFF"/>
+                </a:solidFill>
+                <a:latin typeface="Aptos" pitchFamily="34" charset="0"/>
+                <a:ea typeface="Aptos" pitchFamily="34" charset="-122"/>
+                <a:cs typeface="Aptos" pitchFamily="34" charset="-120"/>
+              </a:rPr>
+              <a:t>Report</a:t>
+            </a:r>
+            <a:endParaRPr lang="en-US" sz="880" dirty="0"/>
+          </a:p>
+        </p:txBody>
+      </p:sp>
+      <p:sp>
+        <p:nvSpPr>
+          <p:cNvPr id="23" name="Text 21"/>
+          <p:cNvSpPr/>
+          <p:nvPr/>
+        </p:nvSpPr>
+        <p:spPr>
+          <a:xfrm>
+            <a:off x="7854696" y="3742639"/>
+            <a:ext cx="3035808" cy="158191"/>
+          </a:xfrm>
+          <a:prstGeom prst="rect">
+            <a:avLst/>
+          </a:prstGeom>
+          <a:noFill/>
+          <a:ln/>
+        </p:spPr>
+        <p:txBody>
+          <a:bodyPr wrap="square" lIns="254" tIns="254" rIns="254" bIns="254" rtlCol="0" anchor="t">
+            <a:normAutofit/>
+          </a:bodyPr>
+          <a:lstStyle/>
+          <a:p>
+            <a:pPr indent="0" marL="0">
+              <a:buNone/>
+            </a:pPr>
+            <a:r>
+              <a:rPr lang="en-US" sz="1120" dirty="0">
+                <a:solidFill>
+                  <a:srgbClr val="17364A"/>
+                </a:solidFill>
+                <a:latin typeface="Aptos" pitchFamily="34" charset="0"/>
+                <a:ea typeface="Aptos" pitchFamily="34" charset="-122"/>
+                <a:cs typeface="Aptos" pitchFamily="34" charset="-120"/>
+              </a:rPr>
+              <a:t>Communication and engagement are stronger when feedback changes the work and the department reports what.</a:t>
+            </a:r>
+            <a:endParaRPr lang="en-US" sz="1120" dirty="0"/>
+          </a:p>
+        </p:txBody>
+      </p:sp>
+      <p:sp>
+        <p:nvSpPr>
+          <p:cNvPr id="24" name="Shape 22"/>
+          <p:cNvSpPr/>
+          <p:nvPr/>
+        </p:nvSpPr>
+        <p:spPr>
+          <a:xfrm>
+            <a:off x="7635240" y="4184294"/>
+            <a:ext cx="3474720" cy="1466698"/>
+          </a:xfrm>
+          <a:prstGeom prst="roundRect">
+            <a:avLst>
+              <a:gd name="adj" fmla="val 7481"/>
             </a:avLst>
           </a:prstGeom>
           <a:solidFill>
@@ -16008,13 +16656,13 @@
       </p:sp>
       <p:sp>
         <p:nvSpPr>
-          <p:cNvPr id="17" name="Text 15"/>
-          <p:cNvSpPr/>
-          <p:nvPr/>
-        </p:nvSpPr>
-        <p:spPr>
-          <a:xfrm>
-            <a:off x="7799832" y="4645152"/>
+          <p:cNvPr id="25" name="Text 23"/>
+          <p:cNvSpPr/>
+          <p:nvPr/>
+        </p:nvSpPr>
+        <p:spPr>
+          <a:xfrm>
+            <a:off x="7799832" y="4330598"/>
             <a:ext cx="3145536" cy="256032"/>
           </a:xfrm>
           <a:prstGeom prst="rect">
@@ -16047,14 +16695,14 @@
       </p:sp>
       <p:sp>
         <p:nvSpPr>
-          <p:cNvPr id="18" name="Text 16"/>
-          <p:cNvSpPr/>
-          <p:nvPr/>
-        </p:nvSpPr>
-        <p:spPr>
-          <a:xfrm>
-            <a:off x="7799832" y="4974336"/>
-            <a:ext cx="3145536" cy="576072"/>
+          <p:cNvPr id="26" name="Text 24"/>
+          <p:cNvSpPr/>
+          <p:nvPr/>
+        </p:nvSpPr>
+        <p:spPr>
+          <a:xfrm>
+            <a:off x="7799832" y="4659782"/>
+            <a:ext cx="3145536" cy="899770"/>
           </a:xfrm>
           <a:prstGeom prst="rect">
             <a:avLst/>
@@ -16080,7 +16728,7 @@
                 <a:ea typeface="Aptos" pitchFamily="34" charset="-122"/>
                 <a:cs typeface="Aptos" pitchFamily="34" charset="-120"/>
               </a:rPr>
-              <a:t>Use the concept to plan transparent communication, gather stakeholder input, protect trust, and make sure affected.</a:t>
+              <a:t>Use the concept to plan transparent communication, gather stakeholder input, protect trust, and make sure affected communities are considered early.</a:t>
             </a:r>
             <a:endParaRPr lang="en-US" sz="1320" dirty="0"/>
           </a:p>
@@ -16449,11 +17097,11 @@
         <p:spPr>
           <a:xfrm>
             <a:off x="7635240" y="1325880"/>
-            <a:ext cx="3474720" cy="1325880"/>
+            <a:ext cx="3474720" cy="1207008"/>
           </a:xfrm>
           <a:prstGeom prst="roundRect">
             <a:avLst>
-              <a:gd name="adj" fmla="val 8276"/>
+              <a:gd name="adj" fmla="val 9091"/>
             </a:avLst>
           </a:prstGeom>
           <a:solidFill>
@@ -16515,7 +17163,7 @@
         <p:spPr>
           <a:xfrm>
             <a:off x="7799832" y="1801368"/>
-            <a:ext cx="3145536" cy="758952"/>
+            <a:ext cx="3145536" cy="640080"/>
           </a:xfrm>
           <a:prstGeom prst="rect">
             <a:avLst/>
@@ -16555,12 +17203,12 @@
         </p:nvSpPr>
         <p:spPr>
           <a:xfrm>
-            <a:off x="7635240" y="2788920"/>
-            <a:ext cx="3474720" cy="1536192"/>
+            <a:off x="7635240" y="2670048"/>
+            <a:ext cx="3474720" cy="1377086"/>
           </a:xfrm>
           <a:prstGeom prst="roundRect">
             <a:avLst>
-              <a:gd name="adj" fmla="val 7143"/>
+              <a:gd name="adj" fmla="val 7968"/>
             </a:avLst>
           </a:prstGeom>
           <a:solidFill>
@@ -16582,7 +17230,7 @@
         </p:nvSpPr>
         <p:spPr>
           <a:xfrm>
-            <a:off x="7799832" y="2935224"/>
+            <a:off x="7799832" y="2816352"/>
             <a:ext cx="3145536" cy="256032"/>
           </a:xfrm>
           <a:prstGeom prst="rect">
@@ -16621,8 +17269,8 @@
         </p:nvSpPr>
         <p:spPr>
           <a:xfrm>
-            <a:off x="7818120" y="3300984"/>
-            <a:ext cx="3090672" cy="877824"/>
+            <a:off x="7818120" y="3182112"/>
+            <a:ext cx="3090672" cy="718718"/>
           </a:xfrm>
           <a:prstGeom prst="rect">
             <a:avLst/>
@@ -16696,12 +17344,12 @@
         </p:nvSpPr>
         <p:spPr>
           <a:xfrm>
-            <a:off x="7635240" y="4498848"/>
-            <a:ext cx="3474720" cy="1143000"/>
+            <a:off x="7635240" y="4184294"/>
+            <a:ext cx="3474720" cy="1466698"/>
           </a:xfrm>
           <a:prstGeom prst="roundRect">
             <a:avLst>
-              <a:gd name="adj" fmla="val 9600"/>
+              <a:gd name="adj" fmla="val 7481"/>
             </a:avLst>
           </a:prstGeom>
           <a:solidFill>
@@ -16723,7 +17371,7 @@
         </p:nvSpPr>
         <p:spPr>
           <a:xfrm>
-            <a:off x="7799832" y="4645152"/>
+            <a:off x="7799832" y="4330598"/>
             <a:ext cx="3145536" cy="256032"/>
           </a:xfrm>
           <a:prstGeom prst="rect">
@@ -16762,8 +17410,8 @@
         </p:nvSpPr>
         <p:spPr>
           <a:xfrm>
-            <a:off x="7799832" y="4974336"/>
-            <a:ext cx="3145536" cy="576072"/>
+            <a:off x="7799832" y="4659782"/>
+            <a:ext cx="3145536" cy="899770"/>
           </a:xfrm>
           <a:prstGeom prst="rect">
             <a:avLst/>
@@ -16789,7 +17437,7 @@
                 <a:ea typeface="Aptos" pitchFamily="34" charset="-122"/>
                 <a:cs typeface="Aptos" pitchFamily="34" charset="-120"/>
               </a:rPr>
-              <a:t>Use the concept to plan transparent communication, gather stakeholder input, protect trust, and make sure affected.</a:t>
+              <a:t>Use the concept to plan transparent communication, gather stakeholder input, protect trust, and make sure affected communities are considered early.</a:t>
             </a:r>
             <a:endParaRPr lang="en-US" sz="1320" dirty="0"/>
           </a:p>
@@ -17158,11 +17806,11 @@
         <p:spPr>
           <a:xfrm>
             <a:off x="7635240" y="1325880"/>
-            <a:ext cx="3474720" cy="1325880"/>
+            <a:ext cx="3474720" cy="1207008"/>
           </a:xfrm>
           <a:prstGeom prst="roundRect">
             <a:avLst>
-              <a:gd name="adj" fmla="val 8276"/>
+              <a:gd name="adj" fmla="val 9091"/>
             </a:avLst>
           </a:prstGeom>
           <a:solidFill>
@@ -17224,7 +17872,7 @@
         <p:spPr>
           <a:xfrm>
             <a:off x="7799832" y="1801368"/>
-            <a:ext cx="3145536" cy="758952"/>
+            <a:ext cx="3145536" cy="640080"/>
           </a:xfrm>
           <a:prstGeom prst="rect">
             <a:avLst/>
@@ -17264,12 +17912,12 @@
         </p:nvSpPr>
         <p:spPr>
           <a:xfrm>
-            <a:off x="7635240" y="2788920"/>
-            <a:ext cx="3474720" cy="1536192"/>
+            <a:off x="7635240" y="2670048"/>
+            <a:ext cx="3474720" cy="1377086"/>
           </a:xfrm>
           <a:prstGeom prst="roundRect">
             <a:avLst>
-              <a:gd name="adj" fmla="val 7143"/>
+              <a:gd name="adj" fmla="val 7968"/>
             </a:avLst>
           </a:prstGeom>
           <a:solidFill>
@@ -17291,7 +17939,7 @@
         </p:nvSpPr>
         <p:spPr>
           <a:xfrm>
-            <a:off x="7799832" y="2935224"/>
+            <a:off x="7799832" y="2816352"/>
             <a:ext cx="3145536" cy="256032"/>
           </a:xfrm>
           <a:prstGeom prst="rect">
@@ -17330,8 +17978,8 @@
         </p:nvSpPr>
         <p:spPr>
           <a:xfrm>
-            <a:off x="7818120" y="3300984"/>
-            <a:ext cx="3090672" cy="877824"/>
+            <a:off x="7818120" y="3182112"/>
+            <a:ext cx="3090672" cy="718718"/>
           </a:xfrm>
           <a:prstGeom prst="rect">
             <a:avLst/>
@@ -17405,12 +18053,12 @@
         </p:nvSpPr>
         <p:spPr>
           <a:xfrm>
-            <a:off x="7635240" y="4498848"/>
-            <a:ext cx="3474720" cy="1143000"/>
+            <a:off x="7635240" y="4184294"/>
+            <a:ext cx="3474720" cy="1466698"/>
           </a:xfrm>
           <a:prstGeom prst="roundRect">
             <a:avLst>
-              <a:gd name="adj" fmla="val 9600"/>
+              <a:gd name="adj" fmla="val 7481"/>
             </a:avLst>
           </a:prstGeom>
           <a:solidFill>
@@ -17432,7 +18080,7 @@
         </p:nvSpPr>
         <p:spPr>
           <a:xfrm>
-            <a:off x="7799832" y="4645152"/>
+            <a:off x="7799832" y="4330598"/>
             <a:ext cx="3145536" cy="256032"/>
           </a:xfrm>
           <a:prstGeom prst="rect">
@@ -17471,8 +18119,8 @@
         </p:nvSpPr>
         <p:spPr>
           <a:xfrm>
-            <a:off x="7799832" y="4974336"/>
-            <a:ext cx="3145536" cy="576072"/>
+            <a:off x="7799832" y="4659782"/>
+            <a:ext cx="3145536" cy="899770"/>
           </a:xfrm>
           <a:prstGeom prst="rect">
             <a:avLst/>
@@ -17498,7 +18146,7 @@
                 <a:ea typeface="Aptos" pitchFamily="34" charset="-122"/>
                 <a:cs typeface="Aptos" pitchFamily="34" charset="-120"/>
               </a:rPr>
-              <a:t>Use the concept to plan transparent communication, gather stakeholder input, protect trust, and make sure affected.</a:t>
+              <a:t>Use the concept to plan transparent communication, gather stakeholder input, protect trust, and make sure affected communities are considered early.</a:t>
             </a:r>
             <a:endParaRPr lang="en-US" sz="1320" dirty="0"/>
           </a:p>

</xml_diff>

<commit_message>
Clean numbered text in module slide boxes
</commit_message>
<xml_diff>
--- a/downloads/presentations/modules/anl-200.pptx
+++ b/downloads/presentations/modules/anl-200.pptx
@@ -11852,7 +11852,7 @@
                 <a:ea typeface="Aptos" pitchFamily="34" charset="-122"/>
                 <a:cs typeface="Aptos" pitchFamily="34" charset="-120"/>
               </a:rPr>
-              <a:t>• 1. What is NLP?</a:t>
+              <a:t>1. What is NLP?</a:t>
             </a:r>
             <a:endParaRPr lang="en-US" sz="1920" dirty="0"/>
           </a:p>
@@ -11869,7 +11869,7 @@
                 <a:ea typeface="Aptos" pitchFamily="34" charset="-122"/>
                 <a:cs typeface="Aptos" pitchFamily="34" charset="-120"/>
               </a:rPr>
-              <a:t>• 2. Which task is an example of information extraction?</a:t>
+              <a:t>2. Which task is an example of information extraction?</a:t>
             </a:r>
             <a:endParaRPr lang="en-US" sz="1920" dirty="0"/>
           </a:p>
@@ -11886,7 +11886,7 @@
                 <a:ea typeface="Aptos" pitchFamily="34" charset="-122"/>
                 <a:cs typeface="Aptos" pitchFamily="34" charset="-120"/>
               </a:rPr>
-              <a:t>• 3. Why is source verification important for NLP outputs?</a:t>
+              <a:t>3. Why is source verification important for NLP outputs?</a:t>
             </a:r>
             <a:endParaRPr lang="en-US" sz="1920" dirty="0"/>
           </a:p>
@@ -11993,7 +11993,7 @@
                 <a:ea typeface="Aptos" pitchFamily="34" charset="-122"/>
                 <a:cs typeface="Aptos" pitchFamily="34" charset="-120"/>
               </a:rPr>
-              <a:t>1. What is NLP?</a:t>
+              <a:t>What is NLP?</a:t>
             </a:r>
             <a:endParaRPr lang="en-US" sz="1220" dirty="0"/>
           </a:p>
@@ -12100,41 +12100,7 @@
                 <a:ea typeface="Aptos" pitchFamily="34" charset="-122"/>
                 <a:cs typeface="Aptos" pitchFamily="34" charset="-120"/>
               </a:rPr>
-              <a:t>1.</a:t>
-            </a:r>
-            <a:endParaRPr lang="en-US" sz="1140" dirty="0"/>
-          </a:p>
-          <a:p>
-            <a:pPr indent="0" marL="0">
-              <a:buNone/>
-            </a:pPr>
-            <a:r>
-              <a:rPr lang="en-US" sz="1140" dirty="0">
-                <a:solidFill>
-                  <a:srgbClr val="17364A"/>
-                </a:solidFill>
-                <a:latin typeface="Aptos" pitchFamily="34" charset="0"/>
-                <a:ea typeface="Aptos" pitchFamily="34" charset="-122"/>
-                <a:cs typeface="Aptos" pitchFamily="34" charset="-120"/>
-              </a:rPr>
               <a:t>What is NLP?</a:t>
-            </a:r>
-            <a:endParaRPr lang="en-US" sz="1140" dirty="0"/>
-          </a:p>
-          <a:p>
-            <a:pPr indent="0" marL="0">
-              <a:buNone/>
-            </a:pPr>
-            <a:r>
-              <a:rPr lang="en-US" sz="1140" dirty="0">
-                <a:solidFill>
-                  <a:srgbClr val="17364A"/>
-                </a:solidFill>
-                <a:latin typeface="Aptos" pitchFamily="34" charset="0"/>
-                <a:ea typeface="Aptos" pitchFamily="34" charset="-122"/>
-                <a:cs typeface="Aptos" pitchFamily="34" charset="-120"/>
-              </a:rPr>
-              <a:t>2.</a:t>
             </a:r>
             <a:endParaRPr lang="en-US" sz="1140" dirty="0"/>
           </a:p>

</xml_diff>